<commit_message>
Slide 10: add GitHub link
Co-Authored-By: Claude Sonnet 5.5 <noreply@anthropic.com>
</commit_message>
<xml_diff>
--- a/presentation/Final_Review_10_Slides.pptx
+++ b/presentation/Final_Review_10_Slides.pptx
@@ -5806,7 +5806,7 @@
         <p:spPr>
           <a:xfrm>
             <a:off x="731520" y="5303520"/>
-            <a:ext cx="6858000" cy="365760"/>
+            <a:ext cx="10698480" cy="365760"/>
           </a:xfrm>
           <a:prstGeom prst="rect">
             <a:avLst/>
@@ -5820,12 +5820,12 @@
           <a:lstStyle/>
           <a:p>
             <a:r>
-              <a:rPr sz="1500" b="0" i="0">
-                <a:solidFill>
-                  <a:srgbClr val="C9342B"/>
-                </a:solidFill>
-              </a:rPr>
-              <a:t>[ paste repository link here ]</a:t>
+              <a:rPr sz="1300" b="1" i="0">
+                <a:solidFill>
+                  <a:srgbClr val="1A1A1A"/>
+                </a:solidFill>
+              </a:rPr>
+              <a:t>https://github.com/jaganath010/A-Scalable-Big-Data-Platform-for-Real-Time-Urban-Air-Quality-Tracking-and-Public-Safety-Alerting</a:t>
             </a:r>
           </a:p>
         </p:txBody>
@@ -5858,7 +5858,7 @@
                   <a:srgbClr val="5A6673"/>
                 </a:solidFill>
               </a:rPr>
-              <a:t>Uploaded: this PPT + PROJECT_REPORT.pdf (docs/), code (scala/, scripts/, hive/, dashboard/), run logs (docs/run_logs/)</a:t>
+              <a:t>Uploaded: this PPT (presentation/) + PROJECT_REPORT.pdf (docs/), code (scala/, scripts/, hive/, dashboard/), run logs (docs/run_logs/)</a:t>
             </a:r>
           </a:p>
         </p:txBody>

</xml_diff>

<commit_message>
Slide 10: add website link
Co-Authored-By: Claude Sonnet 5.5 <noreply@anthropic.com>
</commit_message>
<xml_diff>
--- a/presentation/Final_Review_10_Slides.pptx
+++ b/presentation/Final_Review_10_Slides.pptx
@@ -5568,8 +5568,8 @@
         </p:nvSpPr>
         <p:spPr>
           <a:xfrm>
-            <a:off x="548640" y="1188720"/>
-            <a:ext cx="11109960" cy="3566160"/>
+            <a:off x="548640" y="1143000"/>
+            <a:ext cx="11109960" cy="3291840"/>
           </a:xfrm>
           <a:prstGeom prst="rect">
             <a:avLst/>
@@ -5588,7 +5588,7 @@
               </a:spcAft>
             </a:pPr>
             <a:r>
-              <a:rPr sz="1450" b="0" i="0">
+              <a:rPr sz="1350" b="0" i="0">
                 <a:solidFill>
                   <a:srgbClr val="1A1A1A"/>
                 </a:solidFill>
@@ -5603,7 +5603,7 @@
               </a:spcAft>
             </a:pPr>
             <a:r>
-              <a:rPr sz="1450" b="0" i="0">
+              <a:rPr sz="1350" b="0" i="0">
                 <a:solidFill>
                   <a:srgbClr val="1A1A1A"/>
                 </a:solidFill>
@@ -5618,7 +5618,7 @@
               </a:spcAft>
             </a:pPr>
             <a:r>
-              <a:rPr sz="1450" b="0" i="0">
+              <a:rPr sz="1350" b="0" i="0">
                 <a:solidFill>
                   <a:srgbClr val="1A1A1A"/>
                 </a:solidFill>
@@ -5633,7 +5633,7 @@
               </a:spcAft>
             </a:pPr>
             <a:r>
-              <a:rPr sz="1450" b="0" i="0">
+              <a:rPr sz="1350" b="0" i="0">
                 <a:solidFill>
                   <a:srgbClr val="1A1A1A"/>
                 </a:solidFill>
@@ -5648,7 +5648,7 @@
               </a:spcAft>
             </a:pPr>
             <a:r>
-              <a:rPr sz="1450" b="0" i="0">
+              <a:rPr sz="1350" b="0" i="0">
                 <a:solidFill>
                   <a:srgbClr val="1A1A1A"/>
                 </a:solidFill>
@@ -5663,7 +5663,7 @@
               </a:spcAft>
             </a:pPr>
             <a:r>
-              <a:rPr sz="1450" b="0" i="0">
+              <a:rPr sz="1350" b="0" i="0">
                 <a:solidFill>
                   <a:srgbClr val="1A1A1A"/>
                 </a:solidFill>
@@ -5678,7 +5678,7 @@
               </a:spcAft>
             </a:pPr>
             <a:r>
-              <a:rPr sz="1450" b="0" i="0">
+              <a:rPr sz="1350" b="0" i="0">
                 <a:solidFill>
                   <a:srgbClr val="1A1A1A"/>
                 </a:solidFill>
@@ -5693,7 +5693,7 @@
               </a:spcAft>
             </a:pPr>
             <a:r>
-              <a:rPr sz="1450" b="0" i="0">
+              <a:rPr sz="1350" b="0" i="0">
                 <a:solidFill>
                   <a:srgbClr val="1A1A1A"/>
                 </a:solidFill>
@@ -5708,7 +5708,7 @@
               </a:spcAft>
             </a:pPr>
             <a:r>
-              <a:rPr sz="1450" b="0" i="0">
+              <a:rPr sz="1350" b="0" i="0">
                 <a:solidFill>
                   <a:srgbClr val="1A1A1A"/>
                 </a:solidFill>
@@ -5726,8 +5726,8 @@
         </p:nvSpPr>
         <p:spPr>
           <a:xfrm>
-            <a:off x="548640" y="4846320"/>
-            <a:ext cx="11109960" cy="1325880"/>
+            <a:off x="548640" y="4572000"/>
+            <a:ext cx="11109960" cy="1783080"/>
           </a:xfrm>
           <a:prstGeom prst="rect">
             <a:avLst/>
@@ -5772,7 +5772,7 @@
         </p:nvSpPr>
         <p:spPr>
           <a:xfrm>
-            <a:off x="731520" y="4937760"/>
+            <a:off x="731520" y="4645152"/>
             <a:ext cx="3657600" cy="320040"/>
           </a:xfrm>
           <a:prstGeom prst="rect">
@@ -5805,8 +5805,8 @@
         </p:nvSpPr>
         <p:spPr>
           <a:xfrm>
-            <a:off x="731520" y="5303520"/>
-            <a:ext cx="10698480" cy="365760"/>
+            <a:off x="731520" y="4965192"/>
+            <a:ext cx="10698480" cy="320040"/>
           </a:xfrm>
           <a:prstGeom prst="rect">
             <a:avLst/>
@@ -5820,7 +5820,7 @@
           <a:lstStyle/>
           <a:p>
             <a:r>
-              <a:rPr sz="1300" b="1" i="0">
+              <a:rPr sz="1250" b="1" i="0">
                 <a:solidFill>
                   <a:srgbClr val="1A1A1A"/>
                 </a:solidFill>
@@ -5838,8 +5838,8 @@
         </p:nvSpPr>
         <p:spPr>
           <a:xfrm>
-            <a:off x="731520" y="5715000"/>
-            <a:ext cx="10698480" cy="365760"/>
+            <a:off x="731520" y="5349240"/>
+            <a:ext cx="5486400" cy="320040"/>
           </a:xfrm>
           <a:prstGeom prst="rect">
             <a:avLst/>
@@ -5853,7 +5853,73 @@
           <a:lstStyle/>
           <a:p>
             <a:r>
-              <a:rPr sz="1200" b="0" i="0">
+              <a:rPr sz="1400" b="1" i="0">
+                <a:solidFill>
+                  <a:srgbClr val="0B5F8A"/>
+                </a:solidFill>
+              </a:rPr>
+              <a:t>Website (warning board, GitHub Pages)</a:t>
+            </a:r>
+          </a:p>
+        </p:txBody>
+      </p:sp>
+      <p:sp>
+        <p:nvSpPr>
+          <p:cNvPr id="9" name="TextBox 8"/>
+          <p:cNvSpPr txBox="1"/>
+          <p:nvPr/>
+        </p:nvSpPr>
+        <p:spPr>
+          <a:xfrm>
+            <a:off x="731520" y="5669280"/>
+            <a:ext cx="10698480" cy="320040"/>
+          </a:xfrm>
+          <a:prstGeom prst="rect">
+            <a:avLst/>
+          </a:prstGeom>
+          <a:noFill/>
+        </p:spPr>
+        <p:txBody>
+          <a:bodyPr wrap="square" anchor="t" lIns="0" rIns="0" tIns="0" bIns="0">
+            <a:spAutoFit/>
+          </a:bodyPr>
+          <a:lstStyle/>
+          <a:p>
+            <a:r>
+              <a:rPr sz="1250" b="1" i="0">
+                <a:solidFill>
+                  <a:srgbClr val="1A1A1A"/>
+                </a:solidFill>
+              </a:rPr>
+              <a:t>https://jaganath010.github.io/A-Scalable-Big-Data-Platform-for-Real-Time-Urban-Air-Quality-Tracking-and-Public-Safety-Alerting/</a:t>
+            </a:r>
+          </a:p>
+        </p:txBody>
+      </p:sp>
+      <p:sp>
+        <p:nvSpPr>
+          <p:cNvPr id="10" name="TextBox 9"/>
+          <p:cNvSpPr txBox="1"/>
+          <p:nvPr/>
+        </p:nvSpPr>
+        <p:spPr>
+          <a:xfrm>
+            <a:off x="731520" y="6016752"/>
+            <a:ext cx="10698480" cy="274320"/>
+          </a:xfrm>
+          <a:prstGeom prst="rect">
+            <a:avLst/>
+          </a:prstGeom>
+          <a:noFill/>
+        </p:spPr>
+        <p:txBody>
+          <a:bodyPr wrap="square" anchor="t" lIns="0" rIns="0" tIns="0" bIns="0">
+            <a:spAutoFit/>
+          </a:bodyPr>
+          <a:lstStyle/>
+          <a:p>
+            <a:r>
+              <a:rPr sz="1050" b="0" i="0">
                 <a:solidFill>
                   <a:srgbClr val="5A6673"/>
                 </a:solidFill>

</xml_diff>

<commit_message>
Deck: clickable GitHub and website links on title and references slides
Co-Authored-By: Claude Sonnet 5.5 <noreply@anthropic.com>
</commit_message>
<xml_diff>
--- a/presentation/Final_Review_10_Slides.pptx
+++ b/presentation/Final_Review_10_Slides.pptx
@@ -5465,6 +5465,140 @@
           </a:p>
         </p:txBody>
       </p:sp>
+      <p:sp>
+        <p:nvSpPr>
+          <p:cNvPr id="10" name="TextBox 9"/>
+          <p:cNvSpPr txBox="1"/>
+          <p:nvPr/>
+        </p:nvSpPr>
+        <p:spPr>
+          <a:xfrm>
+            <a:off x="822960" y="5669280"/>
+            <a:ext cx="1005840" cy="320040"/>
+          </a:xfrm>
+          <a:prstGeom prst="rect">
+            <a:avLst/>
+          </a:prstGeom>
+          <a:noFill/>
+        </p:spPr>
+        <p:txBody>
+          <a:bodyPr wrap="square" anchor="t" lIns="0" rIns="0" tIns="0" bIns="0">
+            <a:spAutoFit/>
+          </a:bodyPr>
+          <a:lstStyle/>
+          <a:p>
+            <a:r>
+              <a:rPr sz="1200" b="1" i="0">
+                <a:solidFill>
+                  <a:srgbClr val="1A1A1A"/>
+                </a:solidFill>
+              </a:rPr>
+              <a:t>GitHub:</a:t>
+            </a:r>
+          </a:p>
+        </p:txBody>
+      </p:sp>
+      <p:sp>
+        <p:nvSpPr>
+          <p:cNvPr id="11" name="TextBox 10"/>
+          <p:cNvSpPr txBox="1"/>
+          <p:nvPr/>
+        </p:nvSpPr>
+        <p:spPr>
+          <a:xfrm>
+            <a:off x="1828800" y="5669280"/>
+            <a:ext cx="9875520" cy="320040"/>
+          </a:xfrm>
+          <a:prstGeom prst="rect">
+            <a:avLst/>
+          </a:prstGeom>
+          <a:noFill/>
+        </p:spPr>
+        <p:txBody>
+          <a:bodyPr wrap="square" anchor="t" lIns="0" rIns="0" tIns="0" bIns="0">
+            <a:spAutoFit/>
+          </a:bodyPr>
+          <a:lstStyle/>
+          <a:p>
+            <a:r>
+              <a:rPr sz="1150" b="0" i="0" u="sng">
+                <a:solidFill>
+                  <a:srgbClr val="0B5F8A"/>
+                </a:solidFill>
+                <a:hlinkClick r:id="rId2"/>
+              </a:rPr>
+              <a:t>https://github.com/jaganath010/A-Scalable-Big-Data-Platform-for-Real-Time-Urban-Air-Quality-Tracking-and-Public-Safety-Alerting</a:t>
+            </a:r>
+          </a:p>
+        </p:txBody>
+      </p:sp>
+      <p:sp>
+        <p:nvSpPr>
+          <p:cNvPr id="12" name="TextBox 11"/>
+          <p:cNvSpPr txBox="1"/>
+          <p:nvPr/>
+        </p:nvSpPr>
+        <p:spPr>
+          <a:xfrm>
+            <a:off x="822960" y="6080760"/>
+            <a:ext cx="1005840" cy="320040"/>
+          </a:xfrm>
+          <a:prstGeom prst="rect">
+            <a:avLst/>
+          </a:prstGeom>
+          <a:noFill/>
+        </p:spPr>
+        <p:txBody>
+          <a:bodyPr wrap="square" anchor="t" lIns="0" rIns="0" tIns="0" bIns="0">
+            <a:spAutoFit/>
+          </a:bodyPr>
+          <a:lstStyle/>
+          <a:p>
+            <a:r>
+              <a:rPr sz="1200" b="1" i="0">
+                <a:solidFill>
+                  <a:srgbClr val="1A1A1A"/>
+                </a:solidFill>
+              </a:rPr>
+              <a:t>Website:</a:t>
+            </a:r>
+          </a:p>
+        </p:txBody>
+      </p:sp>
+      <p:sp>
+        <p:nvSpPr>
+          <p:cNvPr id="13" name="TextBox 12"/>
+          <p:cNvSpPr txBox="1"/>
+          <p:nvPr/>
+        </p:nvSpPr>
+        <p:spPr>
+          <a:xfrm>
+            <a:off x="1828800" y="6080760"/>
+            <a:ext cx="9875520" cy="320040"/>
+          </a:xfrm>
+          <a:prstGeom prst="rect">
+            <a:avLst/>
+          </a:prstGeom>
+          <a:noFill/>
+        </p:spPr>
+        <p:txBody>
+          <a:bodyPr wrap="square" anchor="t" lIns="0" rIns="0" tIns="0" bIns="0">
+            <a:spAutoFit/>
+          </a:bodyPr>
+          <a:lstStyle/>
+          <a:p>
+            <a:r>
+              <a:rPr sz="1150" b="0" i="0" u="sng">
+                <a:solidFill>
+                  <a:srgbClr val="0B5F8A"/>
+                </a:solidFill>
+                <a:hlinkClick r:id="rId3"/>
+              </a:rPr>
+              <a:t>https://jaganath010.github.io/A-Scalable-Big-Data-Platform-for-Real-Time-Urban-Air-Quality-Tracking-and-Public-Safety-Alerting/</a:t>
+            </a:r>
+          </a:p>
+        </p:txBody>
+      </p:sp>
     </p:spTree>
   </p:cSld>
   <p:clrMapOvr>
@@ -5820,10 +5954,11 @@
           <a:lstStyle/>
           <a:p>
             <a:r>
-              <a:rPr sz="1250" b="1" i="0">
-                <a:solidFill>
-                  <a:srgbClr val="1A1A1A"/>
-                </a:solidFill>
+              <a:rPr sz="1250" b="1" i="0" u="sng">
+                <a:solidFill>
+                  <a:srgbClr val="0B5F8A"/>
+                </a:solidFill>
+                <a:hlinkClick r:id="rId3"/>
               </a:rPr>
               <a:t>https://github.com/jaganath010/A-Scalable-Big-Data-Platform-for-Real-Time-Urban-Air-Quality-Tracking-and-Public-Safety-Alerting</a:t>
             </a:r>
@@ -5886,10 +6021,11 @@
           <a:lstStyle/>
           <a:p>
             <a:r>
-              <a:rPr sz="1250" b="1" i="0">
-                <a:solidFill>
-                  <a:srgbClr val="1A1A1A"/>
-                </a:solidFill>
+              <a:rPr sz="1250" b="1" i="0" u="sng">
+                <a:solidFill>
+                  <a:srgbClr val="0B5F8A"/>
+                </a:solidFill>
+                <a:hlinkClick r:id="rId4"/>
               </a:rPr>
               <a:t>https://jaganath010.github.io/A-Scalable-Big-Data-Platform-for-Real-Time-Urban-Air-Quality-Tracking-and-Public-Safety-Alerting/</a:t>
             </a:r>

</xml_diff>

<commit_message>
New architecture diagram (slide 4 + docs/images/architecture.png, embedded in README); remove links from title slide
Co-Authored-By: Claude Sonnet 5.5 <noreply@anthropic.com>
</commit_message>
<xml_diff>
--- a/presentation/Final_Review_10_Slides.pptx
+++ b/presentation/Final_Review_10_Slides.pptx
@@ -1631,7 +1631,7 @@
           <a:lstStyle/>
           <a:p>
             <a:r>
-              <a:t>(1.5 min) Walk left to right: sources land in HDFS; the Spark-on-YARN cluster runs Scala jobs for cleaning, features, enrichment and streaming, and PySpark for ML; the model is written to HDFS and loaded by the stream; outputs are Hive, the website and alert messages.</a:t>
+              <a:t>(1.5 min) Left to right: sources are fetched by Python scripts and land in HDFS; Spark on YARN runs the batch layer (Scala cleaning and features, PySpark GBT training) and the speed layer (live enrichment and the streaming scorer); the trained model is loaded by the stream; the alert engine feeds Hive, the warning board and Telegram.</a:t>
             </a:r>
           </a:p>
         </p:txBody>
@@ -5461,140 +5461,6 @@
                 </a:solidFill>
               </a:rPr>
               <a:t>Stack:  Hadoop HDFS · YARN · Spark 3.5 · Scala 2.12 · PySpark MLlib · Structured Streaming · Hive</a:t>
-            </a:r>
-          </a:p>
-        </p:txBody>
-      </p:sp>
-      <p:sp>
-        <p:nvSpPr>
-          <p:cNvPr id="10" name="TextBox 9"/>
-          <p:cNvSpPr txBox="1"/>
-          <p:nvPr/>
-        </p:nvSpPr>
-        <p:spPr>
-          <a:xfrm>
-            <a:off x="822960" y="5669280"/>
-            <a:ext cx="1005840" cy="320040"/>
-          </a:xfrm>
-          <a:prstGeom prst="rect">
-            <a:avLst/>
-          </a:prstGeom>
-          <a:noFill/>
-        </p:spPr>
-        <p:txBody>
-          <a:bodyPr wrap="square" anchor="t" lIns="0" rIns="0" tIns="0" bIns="0">
-            <a:spAutoFit/>
-          </a:bodyPr>
-          <a:lstStyle/>
-          <a:p>
-            <a:r>
-              <a:rPr sz="1200" b="1" i="0">
-                <a:solidFill>
-                  <a:srgbClr val="1A1A1A"/>
-                </a:solidFill>
-              </a:rPr>
-              <a:t>GitHub:</a:t>
-            </a:r>
-          </a:p>
-        </p:txBody>
-      </p:sp>
-      <p:sp>
-        <p:nvSpPr>
-          <p:cNvPr id="11" name="TextBox 10"/>
-          <p:cNvSpPr txBox="1"/>
-          <p:nvPr/>
-        </p:nvSpPr>
-        <p:spPr>
-          <a:xfrm>
-            <a:off x="1828800" y="5669280"/>
-            <a:ext cx="9875520" cy="320040"/>
-          </a:xfrm>
-          <a:prstGeom prst="rect">
-            <a:avLst/>
-          </a:prstGeom>
-          <a:noFill/>
-        </p:spPr>
-        <p:txBody>
-          <a:bodyPr wrap="square" anchor="t" lIns="0" rIns="0" tIns="0" bIns="0">
-            <a:spAutoFit/>
-          </a:bodyPr>
-          <a:lstStyle/>
-          <a:p>
-            <a:r>
-              <a:rPr sz="1150" b="0" i="0" u="sng">
-                <a:solidFill>
-                  <a:srgbClr val="0B5F8A"/>
-                </a:solidFill>
-                <a:hlinkClick r:id="rId2"/>
-              </a:rPr>
-              <a:t>https://github.com/jaganath010/A-Scalable-Big-Data-Platform-for-Real-Time-Urban-Air-Quality-Tracking-and-Public-Safety-Alerting</a:t>
-            </a:r>
-          </a:p>
-        </p:txBody>
-      </p:sp>
-      <p:sp>
-        <p:nvSpPr>
-          <p:cNvPr id="12" name="TextBox 11"/>
-          <p:cNvSpPr txBox="1"/>
-          <p:nvPr/>
-        </p:nvSpPr>
-        <p:spPr>
-          <a:xfrm>
-            <a:off x="822960" y="6080760"/>
-            <a:ext cx="1005840" cy="320040"/>
-          </a:xfrm>
-          <a:prstGeom prst="rect">
-            <a:avLst/>
-          </a:prstGeom>
-          <a:noFill/>
-        </p:spPr>
-        <p:txBody>
-          <a:bodyPr wrap="square" anchor="t" lIns="0" rIns="0" tIns="0" bIns="0">
-            <a:spAutoFit/>
-          </a:bodyPr>
-          <a:lstStyle/>
-          <a:p>
-            <a:r>
-              <a:rPr sz="1200" b="1" i="0">
-                <a:solidFill>
-                  <a:srgbClr val="1A1A1A"/>
-                </a:solidFill>
-              </a:rPr>
-              <a:t>Website:</a:t>
-            </a:r>
-          </a:p>
-        </p:txBody>
-      </p:sp>
-      <p:sp>
-        <p:nvSpPr>
-          <p:cNvPr id="13" name="TextBox 12"/>
-          <p:cNvSpPr txBox="1"/>
-          <p:nvPr/>
-        </p:nvSpPr>
-        <p:spPr>
-          <a:xfrm>
-            <a:off x="1828800" y="6080760"/>
-            <a:ext cx="9875520" cy="320040"/>
-          </a:xfrm>
-          <a:prstGeom prst="rect">
-            <a:avLst/>
-          </a:prstGeom>
-          <a:noFill/>
-        </p:spPr>
-        <p:txBody>
-          <a:bodyPr wrap="square" anchor="t" lIns="0" rIns="0" tIns="0" bIns="0">
-            <a:spAutoFit/>
-          </a:bodyPr>
-          <a:lstStyle/>
-          <a:p>
-            <a:r>
-              <a:rPr sz="1150" b="0" i="0" u="sng">
-                <a:solidFill>
-                  <a:srgbClr val="0B5F8A"/>
-                </a:solidFill>
-                <a:hlinkClick r:id="rId3"/>
-              </a:rPr>
-              <a:t>https://jaganath010.github.io/A-Scalable-Big-Data-Platform-for-Real-Time-Urban-Air-Quality-Tracking-and-Public-Safety-Alerting/</a:t>
             </a:r>
           </a:p>
         </p:txBody>
@@ -12070,8 +11936,8 @@
         </p:nvSpPr>
         <p:spPr>
           <a:xfrm>
-            <a:off x="548640" y="1097280"/>
-            <a:ext cx="2377440" cy="274320"/>
+            <a:off x="411480" y="1024128"/>
+            <a:ext cx="2194560" cy="256032"/>
           </a:xfrm>
           <a:prstGeom prst="rect">
             <a:avLst/>
@@ -12084,13 +11950,14 @@
           </a:bodyPr>
           <a:lstStyle/>
           <a:p>
-            <a:r>
-              <a:rPr sz="1100" b="1" i="0">
+            <a:pPr algn="ctr"/>
+            <a:r>
+              <a:rPr sz="1050" b="1" i="0">
                 <a:solidFill>
                   <a:srgbClr val="6B7785"/>
                 </a:solidFill>
               </a:rPr>
-              <a:t>DATA SOURCES</a:t>
+              <a:t>1  DATA SOURCES</a:t>
             </a:r>
           </a:p>
         </p:txBody>
@@ -12103,8 +11970,364 @@
         </p:nvSpPr>
         <p:spPr>
           <a:xfrm>
-            <a:off x="548640" y="1371600"/>
-            <a:ext cx="2377440" cy="822960"/>
+            <a:off x="411480" y="1280160"/>
+            <a:ext cx="2194560" cy="27432"/>
+          </a:xfrm>
+          <a:prstGeom prst="rect">
+            <a:avLst/>
+          </a:prstGeom>
+          <a:solidFill>
+            <a:srgbClr val="D9DFE7"/>
+          </a:solidFill>
+          <a:ln>
+            <a:noFill/>
+          </a:ln>
+          <a:effectLst/>
+        </p:spPr>
+        <p:style>
+          <a:lnRef idx="1">
+            <a:schemeClr val="accent1"/>
+          </a:lnRef>
+          <a:fillRef idx="3">
+            <a:schemeClr val="accent1"/>
+          </a:fillRef>
+          <a:effectRef idx="2">
+            <a:schemeClr val="accent1"/>
+          </a:effectRef>
+          <a:fontRef idx="minor">
+            <a:schemeClr val="lt1"/>
+          </a:fontRef>
+        </p:style>
+        <p:txBody>
+          <a:bodyPr rtlCol="0" anchor="ctr"/>
+          <a:lstStyle/>
+          <a:p>
+            <a:pPr algn="ctr"/>
+          </a:p>
+        </p:txBody>
+      </p:sp>
+      <p:sp>
+        <p:nvSpPr>
+          <p:cNvPr id="6" name="TextBox 5"/>
+          <p:cNvSpPr txBox="1"/>
+          <p:nvPr/>
+        </p:nvSpPr>
+        <p:spPr>
+          <a:xfrm>
+            <a:off x="2834640" y="1024128"/>
+            <a:ext cx="1463040" cy="256032"/>
+          </a:xfrm>
+          <a:prstGeom prst="rect">
+            <a:avLst/>
+          </a:prstGeom>
+          <a:noFill/>
+        </p:spPr>
+        <p:txBody>
+          <a:bodyPr wrap="square" anchor="t" lIns="0" rIns="0" tIns="0" bIns="0">
+            <a:spAutoFit/>
+          </a:bodyPr>
+          <a:lstStyle/>
+          <a:p>
+            <a:pPr algn="ctr"/>
+            <a:r>
+              <a:rPr sz="1050" b="1" i="0">
+                <a:solidFill>
+                  <a:srgbClr val="6B7785"/>
+                </a:solidFill>
+              </a:rPr>
+              <a:t>2  INGEST</a:t>
+            </a:r>
+          </a:p>
+        </p:txBody>
+      </p:sp>
+      <p:sp>
+        <p:nvSpPr>
+          <p:cNvPr id="7" name="Rectangle 6"/>
+          <p:cNvSpPr/>
+          <p:nvPr/>
+        </p:nvSpPr>
+        <p:spPr>
+          <a:xfrm>
+            <a:off x="2834640" y="1280160"/>
+            <a:ext cx="1463040" cy="27432"/>
+          </a:xfrm>
+          <a:prstGeom prst="rect">
+            <a:avLst/>
+          </a:prstGeom>
+          <a:solidFill>
+            <a:srgbClr val="D9DFE7"/>
+          </a:solidFill>
+          <a:ln>
+            <a:noFill/>
+          </a:ln>
+          <a:effectLst/>
+        </p:spPr>
+        <p:style>
+          <a:lnRef idx="1">
+            <a:schemeClr val="accent1"/>
+          </a:lnRef>
+          <a:fillRef idx="3">
+            <a:schemeClr val="accent1"/>
+          </a:fillRef>
+          <a:effectRef idx="2">
+            <a:schemeClr val="accent1"/>
+          </a:effectRef>
+          <a:fontRef idx="minor">
+            <a:schemeClr val="lt1"/>
+          </a:fontRef>
+        </p:style>
+        <p:txBody>
+          <a:bodyPr rtlCol="0" anchor="ctr"/>
+          <a:lstStyle/>
+          <a:p>
+            <a:pPr algn="ctr"/>
+          </a:p>
+        </p:txBody>
+      </p:sp>
+      <p:sp>
+        <p:nvSpPr>
+          <p:cNvPr id="8" name="TextBox 7"/>
+          <p:cNvSpPr txBox="1"/>
+          <p:nvPr/>
+        </p:nvSpPr>
+        <p:spPr>
+          <a:xfrm>
+            <a:off x="4526280" y="1024128"/>
+            <a:ext cx="1737360" cy="256032"/>
+          </a:xfrm>
+          <a:prstGeom prst="rect">
+            <a:avLst/>
+          </a:prstGeom>
+          <a:noFill/>
+        </p:spPr>
+        <p:txBody>
+          <a:bodyPr wrap="square" anchor="t" lIns="0" rIns="0" tIns="0" bIns="0">
+            <a:spAutoFit/>
+          </a:bodyPr>
+          <a:lstStyle/>
+          <a:p>
+            <a:pPr algn="ctr"/>
+            <a:r>
+              <a:rPr sz="1050" b="1" i="0">
+                <a:solidFill>
+                  <a:srgbClr val="6B7785"/>
+                </a:solidFill>
+              </a:rPr>
+              <a:t>3  STORAGE</a:t>
+            </a:r>
+          </a:p>
+        </p:txBody>
+      </p:sp>
+      <p:sp>
+        <p:nvSpPr>
+          <p:cNvPr id="9" name="Rectangle 8"/>
+          <p:cNvSpPr/>
+          <p:nvPr/>
+        </p:nvSpPr>
+        <p:spPr>
+          <a:xfrm>
+            <a:off x="4526280" y="1280160"/>
+            <a:ext cx="1737360" cy="27432"/>
+          </a:xfrm>
+          <a:prstGeom prst="rect">
+            <a:avLst/>
+          </a:prstGeom>
+          <a:solidFill>
+            <a:srgbClr val="D9DFE7"/>
+          </a:solidFill>
+          <a:ln>
+            <a:noFill/>
+          </a:ln>
+          <a:effectLst/>
+        </p:spPr>
+        <p:style>
+          <a:lnRef idx="1">
+            <a:schemeClr val="accent1"/>
+          </a:lnRef>
+          <a:fillRef idx="3">
+            <a:schemeClr val="accent1"/>
+          </a:fillRef>
+          <a:effectRef idx="2">
+            <a:schemeClr val="accent1"/>
+          </a:effectRef>
+          <a:fontRef idx="minor">
+            <a:schemeClr val="lt1"/>
+          </a:fontRef>
+        </p:style>
+        <p:txBody>
+          <a:bodyPr rtlCol="0" anchor="ctr"/>
+          <a:lstStyle/>
+          <a:p>
+            <a:pPr algn="ctr"/>
+          </a:p>
+        </p:txBody>
+      </p:sp>
+      <p:sp>
+        <p:nvSpPr>
+          <p:cNvPr id="10" name="TextBox 9"/>
+          <p:cNvSpPr txBox="1"/>
+          <p:nvPr/>
+        </p:nvSpPr>
+        <p:spPr>
+          <a:xfrm>
+            <a:off x="6492240" y="1024128"/>
+            <a:ext cx="3794760" cy="256032"/>
+          </a:xfrm>
+          <a:prstGeom prst="rect">
+            <a:avLst/>
+          </a:prstGeom>
+          <a:noFill/>
+        </p:spPr>
+        <p:txBody>
+          <a:bodyPr wrap="square" anchor="t" lIns="0" rIns="0" tIns="0" bIns="0">
+            <a:spAutoFit/>
+          </a:bodyPr>
+          <a:lstStyle/>
+          <a:p>
+            <a:pPr algn="ctr"/>
+            <a:r>
+              <a:rPr sz="1050" b="1" i="0">
+                <a:solidFill>
+                  <a:srgbClr val="6B7785"/>
+                </a:solidFill>
+              </a:rPr>
+              <a:t>4  PROCESSING</a:t>
+            </a:r>
+          </a:p>
+        </p:txBody>
+      </p:sp>
+      <p:sp>
+        <p:nvSpPr>
+          <p:cNvPr id="11" name="Rectangle 10"/>
+          <p:cNvSpPr/>
+          <p:nvPr/>
+        </p:nvSpPr>
+        <p:spPr>
+          <a:xfrm>
+            <a:off x="6492240" y="1280160"/>
+            <a:ext cx="3794760" cy="27432"/>
+          </a:xfrm>
+          <a:prstGeom prst="rect">
+            <a:avLst/>
+          </a:prstGeom>
+          <a:solidFill>
+            <a:srgbClr val="D9DFE7"/>
+          </a:solidFill>
+          <a:ln>
+            <a:noFill/>
+          </a:ln>
+          <a:effectLst/>
+        </p:spPr>
+        <p:style>
+          <a:lnRef idx="1">
+            <a:schemeClr val="accent1"/>
+          </a:lnRef>
+          <a:fillRef idx="3">
+            <a:schemeClr val="accent1"/>
+          </a:fillRef>
+          <a:effectRef idx="2">
+            <a:schemeClr val="accent1"/>
+          </a:effectRef>
+          <a:fontRef idx="minor">
+            <a:schemeClr val="lt1"/>
+          </a:fontRef>
+        </p:style>
+        <p:txBody>
+          <a:bodyPr rtlCol="0" anchor="ctr"/>
+          <a:lstStyle/>
+          <a:p>
+            <a:pPr algn="ctr"/>
+          </a:p>
+        </p:txBody>
+      </p:sp>
+      <p:sp>
+        <p:nvSpPr>
+          <p:cNvPr id="12" name="TextBox 11"/>
+          <p:cNvSpPr txBox="1"/>
+          <p:nvPr/>
+        </p:nvSpPr>
+        <p:spPr>
+          <a:xfrm>
+            <a:off x="10515600" y="1024128"/>
+            <a:ext cx="1280160" cy="256032"/>
+          </a:xfrm>
+          <a:prstGeom prst="rect">
+            <a:avLst/>
+          </a:prstGeom>
+          <a:noFill/>
+        </p:spPr>
+        <p:txBody>
+          <a:bodyPr wrap="square" anchor="t" lIns="0" rIns="0" tIns="0" bIns="0">
+            <a:spAutoFit/>
+          </a:bodyPr>
+          <a:lstStyle/>
+          <a:p>
+            <a:pPr algn="ctr"/>
+            <a:r>
+              <a:rPr sz="1050" b="1" i="0">
+                <a:solidFill>
+                  <a:srgbClr val="6B7785"/>
+                </a:solidFill>
+              </a:rPr>
+              <a:t>5  SERVE / ALERT</a:t>
+            </a:r>
+          </a:p>
+        </p:txBody>
+      </p:sp>
+      <p:sp>
+        <p:nvSpPr>
+          <p:cNvPr id="13" name="Rectangle 12"/>
+          <p:cNvSpPr/>
+          <p:nvPr/>
+        </p:nvSpPr>
+        <p:spPr>
+          <a:xfrm>
+            <a:off x="10515600" y="1280160"/>
+            <a:ext cx="1280160" cy="27432"/>
+          </a:xfrm>
+          <a:prstGeom prst="rect">
+            <a:avLst/>
+          </a:prstGeom>
+          <a:solidFill>
+            <a:srgbClr val="D9DFE7"/>
+          </a:solidFill>
+          <a:ln>
+            <a:noFill/>
+          </a:ln>
+          <a:effectLst/>
+        </p:spPr>
+        <p:style>
+          <a:lnRef idx="1">
+            <a:schemeClr val="accent1"/>
+          </a:lnRef>
+          <a:fillRef idx="3">
+            <a:schemeClr val="accent1"/>
+          </a:fillRef>
+          <a:effectRef idx="2">
+            <a:schemeClr val="accent1"/>
+          </a:effectRef>
+          <a:fontRef idx="minor">
+            <a:schemeClr val="lt1"/>
+          </a:fontRef>
+        </p:style>
+        <p:txBody>
+          <a:bodyPr rtlCol="0" anchor="ctr"/>
+          <a:lstStyle/>
+          <a:p>
+            <a:pPr algn="ctr"/>
+          </a:p>
+        </p:txBody>
+      </p:sp>
+      <p:sp>
+        <p:nvSpPr>
+          <p:cNvPr id="14" name="Rectangle 13"/>
+          <p:cNvSpPr/>
+          <p:nvPr/>
+        </p:nvSpPr>
+        <p:spPr>
+          <a:xfrm>
+            <a:off x="411480" y="1463040"/>
+            <a:ext cx="2194560" cy="822960"/>
           </a:xfrm>
           <a:prstGeom prst="rect">
             <a:avLst/>
@@ -12141,14 +12364,14 @@
       </p:sp>
       <p:sp>
         <p:nvSpPr>
-          <p:cNvPr id="6" name="TextBox 5"/>
+          <p:cNvPr id="15" name="TextBox 14"/>
           <p:cNvSpPr txBox="1"/>
           <p:nvPr/>
         </p:nvSpPr>
         <p:spPr>
           <a:xfrm>
-            <a:off x="603503" y="1371600"/>
-            <a:ext cx="2267712" cy="822960"/>
+            <a:off x="457200" y="1463040"/>
+            <a:ext cx="2103120" cy="822960"/>
           </a:xfrm>
           <a:prstGeom prst="rect">
             <a:avLst/>
@@ -12163,7 +12386,7 @@
           <a:p>
             <a:pPr algn="ctr"/>
             <a:r>
-              <a:rPr sz="1200" b="1" i="0">
+              <a:rPr sz="1050" b="1" i="0">
                 <a:solidFill>
                   <a:srgbClr val="FFFFFF"/>
                 </a:solidFill>
@@ -12174,26 +12397,26 @@
           <a:p>
             <a:pPr algn="ctr"/>
             <a:r>
-              <a:rPr sz="1200" b="1" i="0">
+              <a:rPr sz="1050" b="1" i="0">
                 <a:solidFill>
                   <a:srgbClr val="FFFFFF"/>
                 </a:solidFill>
               </a:rPr>
-              <a:t>146.3 M rows</a:t>
-            </a:r>
-          </a:p>
-        </p:txBody>
-      </p:sp>
-      <p:sp>
-        <p:nvSpPr>
-          <p:cNvPr id="7" name="Rectangle 6"/>
+              <a:t>2010–2023 · 146.3 M rows</a:t>
+            </a:r>
+          </a:p>
+        </p:txBody>
+      </p:sp>
+      <p:sp>
+        <p:nvSpPr>
+          <p:cNvPr id="16" name="Rectangle 15"/>
           <p:cNvSpPr/>
           <p:nvPr/>
         </p:nvSpPr>
         <p:spPr>
           <a:xfrm>
-            <a:off x="548640" y="2377440"/>
-            <a:ext cx="2377440" cy="822960"/>
+            <a:off x="411480" y="2423160"/>
+            <a:ext cx="2194560" cy="822960"/>
           </a:xfrm>
           <a:prstGeom prst="rect">
             <a:avLst/>
@@ -12230,14 +12453,14 @@
       </p:sp>
       <p:sp>
         <p:nvSpPr>
-          <p:cNvPr id="8" name="TextBox 7"/>
+          <p:cNvPr id="17" name="TextBox 16"/>
           <p:cNvSpPr txBox="1"/>
           <p:nvPr/>
         </p:nvSpPr>
         <p:spPr>
           <a:xfrm>
-            <a:off x="603503" y="2377440"/>
-            <a:ext cx="2267712" cy="822960"/>
+            <a:off x="457200" y="2423160"/>
+            <a:ext cx="2103120" cy="822960"/>
           </a:xfrm>
           <a:prstGeom prst="rect">
             <a:avLst/>
@@ -12252,7 +12475,7 @@
           <a:p>
             <a:pPr algn="ctr"/>
             <a:r>
-              <a:rPr sz="1200" b="1" i="0">
+              <a:rPr sz="1050" b="1" i="0">
                 <a:solidFill>
                   <a:srgbClr val="FFFFFF"/>
                 </a:solidFill>
@@ -12263,26 +12486,26 @@
           <a:p>
             <a:pPr algn="ctr"/>
             <a:r>
-              <a:rPr sz="1200" b="1" i="0">
+              <a:rPr sz="1050" b="1" i="0">
                 <a:solidFill>
                   <a:srgbClr val="FFFFFF"/>
                 </a:solidFill>
               </a:rPr>
-              <a:t>8.3 M rows</a:t>
-            </a:r>
-          </a:p>
-        </p:txBody>
-      </p:sp>
-      <p:sp>
-        <p:nvSpPr>
-          <p:cNvPr id="9" name="Rectangle 8"/>
+              <a:t>2022–26 · 8.3 M rows</a:t>
+            </a:r>
+          </a:p>
+        </p:txBody>
+      </p:sp>
+      <p:sp>
+        <p:nvSpPr>
+          <p:cNvPr id="18" name="Rectangle 17"/>
           <p:cNvSpPr/>
           <p:nvPr/>
         </p:nvSpPr>
         <p:spPr>
           <a:xfrm>
-            <a:off x="548640" y="3383280"/>
-            <a:ext cx="2377440" cy="822960"/>
+            <a:off x="411480" y="3383280"/>
+            <a:ext cx="2194560" cy="822960"/>
           </a:xfrm>
           <a:prstGeom prst="rect">
             <a:avLst/>
@@ -12319,14 +12542,14 @@
       </p:sp>
       <p:sp>
         <p:nvSpPr>
-          <p:cNvPr id="10" name="TextBox 9"/>
+          <p:cNvPr id="19" name="TextBox 18"/>
           <p:cNvSpPr txBox="1"/>
           <p:nvPr/>
         </p:nvSpPr>
         <p:spPr>
           <a:xfrm>
-            <a:off x="603503" y="3383280"/>
-            <a:ext cx="2267712" cy="822960"/>
+            <a:off x="457200" y="3383280"/>
+            <a:ext cx="2103120" cy="822960"/>
           </a:xfrm>
           <a:prstGeom prst="rect">
             <a:avLst/>
@@ -12341,37 +12564,37 @@
           <a:p>
             <a:pPr algn="ctr"/>
             <a:r>
-              <a:rPr sz="1200" b="1" i="0">
+              <a:rPr sz="1050" b="1" i="0">
                 <a:solidFill>
                   <a:srgbClr val="FFFFFF"/>
                 </a:solidFill>
               </a:rPr>
-              <a:t>CAMS + weather</a:t>
+              <a:t>CAMS + weather APIs</a:t>
             </a:r>
           </a:p>
           <a:p>
             <a:pPr algn="ctr"/>
             <a:r>
-              <a:rPr sz="1200" b="1" i="0">
+              <a:rPr sz="1050" b="1" i="0">
                 <a:solidFill>
                   <a:srgbClr val="FFFFFF"/>
                 </a:solidFill>
               </a:rPr>
-              <a:t>live APIs (230 cities)</a:t>
-            </a:r>
-          </a:p>
-        </p:txBody>
-      </p:sp>
-      <p:sp>
-        <p:nvSpPr>
-          <p:cNvPr id="11" name="Rectangle 10"/>
+              <a:t>live · 230 cities (keyless)</a:t>
+            </a:r>
+          </a:p>
+        </p:txBody>
+      </p:sp>
+      <p:sp>
+        <p:nvSpPr>
+          <p:cNvPr id="20" name="Rectangle 19"/>
           <p:cNvSpPr/>
           <p:nvPr/>
         </p:nvSpPr>
         <p:spPr>
           <a:xfrm>
-            <a:off x="548640" y="4389120"/>
-            <a:ext cx="2377440" cy="822960"/>
+            <a:off x="411480" y="4343400"/>
+            <a:ext cx="2194560" cy="822960"/>
           </a:xfrm>
           <a:prstGeom prst="rect">
             <a:avLst/>
@@ -12408,14 +12631,14 @@
       </p:sp>
       <p:sp>
         <p:nvSpPr>
-          <p:cNvPr id="12" name="TextBox 11"/>
+          <p:cNvPr id="21" name="TextBox 20"/>
           <p:cNvSpPr txBox="1"/>
           <p:nvPr/>
         </p:nvSpPr>
         <p:spPr>
           <a:xfrm>
-            <a:off x="603503" y="4389120"/>
-            <a:ext cx="2267712" cy="822960"/>
+            <a:off x="457200" y="4343400"/>
+            <a:ext cx="2103120" cy="822960"/>
           </a:xfrm>
           <a:prstGeom prst="rect">
             <a:avLst/>
@@ -12430,7 +12653,7 @@
           <a:p>
             <a:pPr algn="ctr"/>
             <a:r>
-              <a:rPr sz="1200" b="1" i="0">
+              <a:rPr sz="1050" b="1" i="0">
                 <a:solidFill>
                   <a:srgbClr val="FFFFFF"/>
                 </a:solidFill>
@@ -12441,26 +12664,194 @@
           <a:p>
             <a:pPr algn="ctr"/>
             <a:r>
-              <a:rPr sz="1200" b="1" i="0">
+              <a:rPr sz="1050" b="1" i="0">
                 <a:solidFill>
                   <a:srgbClr val="FFFFFF"/>
                 </a:solidFill>
               </a:rPr>
               <a:t>traffic, urbanization</a:t>
+            </a:r>
+          </a:p>
+        </p:txBody>
+      </p:sp>
+      <p:sp>
+        <p:nvSpPr>
+          <p:cNvPr id="22" name="Rectangle 21"/>
+          <p:cNvSpPr/>
+          <p:nvPr/>
+        </p:nvSpPr>
+        <p:spPr>
+          <a:xfrm>
+            <a:off x="2834640" y="1463040"/>
+            <a:ext cx="1463040" cy="3566160"/>
+          </a:xfrm>
+          <a:prstGeom prst="rect">
+            <a:avLst/>
+          </a:prstGeom>
+          <a:solidFill>
+            <a:srgbClr val="F1F5F8"/>
+          </a:solidFill>
+          <a:ln w="6350">
+            <a:solidFill>
+              <a:srgbClr val="D9DFE7"/>
+            </a:solidFill>
+          </a:ln>
+          <a:effectLst/>
+        </p:spPr>
+        <p:style>
+          <a:lnRef idx="1">
+            <a:schemeClr val="accent1"/>
+          </a:lnRef>
+          <a:fillRef idx="3">
+            <a:schemeClr val="accent1"/>
+          </a:fillRef>
+          <a:effectRef idx="2">
+            <a:schemeClr val="accent1"/>
+          </a:effectRef>
+          <a:fontRef idx="minor">
+            <a:schemeClr val="lt1"/>
+          </a:fontRef>
+        </p:style>
+        <p:txBody>
+          <a:bodyPr rtlCol="0" anchor="ctr"/>
+          <a:lstStyle/>
+          <a:p>
+            <a:pPr algn="ctr"/>
+          </a:p>
+        </p:txBody>
+      </p:sp>
+      <p:sp>
+        <p:nvSpPr>
+          <p:cNvPr id="23" name="TextBox 22"/>
+          <p:cNvSpPr txBox="1"/>
+          <p:nvPr/>
+        </p:nvSpPr>
+        <p:spPr>
+          <a:xfrm>
+            <a:off x="2880360" y="1554480"/>
+            <a:ext cx="1371600" cy="3383280"/>
+          </a:xfrm>
+          <a:prstGeom prst="rect">
+            <a:avLst/>
+          </a:prstGeom>
+          <a:noFill/>
+        </p:spPr>
+        <p:txBody>
+          <a:bodyPr wrap="square" anchor="t" lIns="0" rIns="0" tIns="0" bIns="0">
+            <a:spAutoFit/>
+          </a:bodyPr>
+          <a:lstStyle/>
+          <a:p>
+            <a:pPr algn="ctr"/>
+            <a:r>
+              <a:rPr sz="1050" b="0" i="0">
+                <a:solidFill>
+                  <a:srgbClr val="1A1A1A"/>
+                </a:solidFill>
+              </a:rPr>
+              <a:t>Python fetchers</a:t>
+            </a:r>
+          </a:p>
+          <a:p>
+            <a:pPr algn="ctr"/>
+            <a:r>
+              <a:rPr sz="1050" b="0" i="0">
+                <a:solidFill>
+                  <a:srgbClr val="1A1A1A"/>
+                </a:solidFill>
+              </a:rPr>
+              <a:t/>
+            </a:r>
+          </a:p>
+          <a:p>
+            <a:pPr algn="ctr"/>
+            <a:r>
+              <a:rPr sz="1050" b="0" i="0">
+                <a:solidFill>
+                  <a:srgbClr val="1A1A1A"/>
+                </a:solidFill>
+              </a:rPr>
+              <a:t>00e / 00f / 00g</a:t>
+            </a:r>
+          </a:p>
+          <a:p>
+            <a:pPr algn="ctr"/>
+            <a:r>
+              <a:rPr sz="1050" b="0" i="0">
+                <a:solidFill>
+                  <a:srgbClr val="1A1A1A"/>
+                </a:solidFill>
+              </a:rPr>
+              <a:t>HTTP, no API key</a:t>
+            </a:r>
+          </a:p>
+          <a:p>
+            <a:pPr algn="ctr"/>
+            <a:r>
+              <a:rPr sz="1050" b="0" i="0">
+                <a:solidFill>
+                  <a:srgbClr val="1A1A1A"/>
+                </a:solidFill>
+              </a:rPr>
+              <a:t/>
+            </a:r>
+          </a:p>
+          <a:p>
+            <a:pPr algn="ctr"/>
+            <a:r>
+              <a:rPr sz="1050" b="0" i="0">
+                <a:solidFill>
+                  <a:srgbClr val="1A1A1A"/>
+                </a:solidFill>
+              </a:rPr>
+              <a:t>run_daily_live_cycle</a:t>
+            </a:r>
+          </a:p>
+          <a:p>
+            <a:pPr algn="ctr"/>
+            <a:r>
+              <a:rPr sz="1050" b="0" i="0">
+                <a:solidFill>
+                  <a:srgbClr val="1A1A1A"/>
+                </a:solidFill>
+              </a:rPr>
+              <a:t>run_hourly_cycle</a:t>
+            </a:r>
+          </a:p>
+          <a:p>
+            <a:pPr algn="ctr"/>
+            <a:r>
+              <a:rPr sz="1050" b="0" i="0">
+                <a:solidFill>
+                  <a:srgbClr val="1A1A1A"/>
+                </a:solidFill>
+              </a:rPr>
+              <a:t/>
+            </a:r>
+          </a:p>
+          <a:p>
+            <a:pPr algn="ctr"/>
+            <a:r>
+              <a:rPr sz="1050" b="0" i="0">
+                <a:solidFill>
+                  <a:srgbClr val="1A1A1A"/>
+                </a:solidFill>
+              </a:rPr>
+              <a:t>upload to HDFS</a:t>
             </a:r>
           </a:p>
         </p:txBody>
       </p:sp>
       <p:cxnSp>
         <p:nvCxnSpPr>
-          <p:cNvPr id="13" name="Connector 12"/>
+          <p:cNvPr id="24" name="Connector 23"/>
           <p:cNvCxnSpPr/>
           <p:nvPr/>
         </p:nvCxnSpPr>
         <p:spPr>
           <a:xfrm>
-            <a:off x="2926080" y="1783080"/>
-            <a:ext cx="502920" cy="1508760"/>
+            <a:off x="2606040" y="1874519"/>
+            <a:ext cx="228600" cy="0"/>
           </a:xfrm>
           <a:prstGeom prst="line">
             <a:avLst/>
@@ -12489,14 +12880,14 @@
       </p:cxnSp>
       <p:cxnSp>
         <p:nvCxnSpPr>
-          <p:cNvPr id="14" name="Connector 13"/>
+          <p:cNvPr id="25" name="Connector 24"/>
           <p:cNvCxnSpPr/>
           <p:nvPr/>
         </p:nvCxnSpPr>
         <p:spPr>
           <a:xfrm>
-            <a:off x="2926080" y="2788920"/>
-            <a:ext cx="502920" cy="502920"/>
+            <a:off x="2606040" y="2834639"/>
+            <a:ext cx="228600" cy="0"/>
           </a:xfrm>
           <a:prstGeom prst="line">
             <a:avLst/>
@@ -12525,14 +12916,14 @@
       </p:cxnSp>
       <p:cxnSp>
         <p:nvCxnSpPr>
-          <p:cNvPr id="15" name="Connector 14"/>
+          <p:cNvPr id="26" name="Connector 25"/>
           <p:cNvCxnSpPr/>
           <p:nvPr/>
         </p:nvCxnSpPr>
         <p:spPr>
-          <a:xfrm flipV="1">
-            <a:off x="2926080" y="3291840"/>
-            <a:ext cx="502920" cy="502920"/>
+          <a:xfrm>
+            <a:off x="2606040" y="3794760"/>
+            <a:ext cx="228600" cy="0"/>
           </a:xfrm>
           <a:prstGeom prst="line">
             <a:avLst/>
@@ -12561,14 +12952,14 @@
       </p:cxnSp>
       <p:cxnSp>
         <p:nvCxnSpPr>
-          <p:cNvPr id="16" name="Connector 15"/>
+          <p:cNvPr id="27" name="Connector 26"/>
           <p:cNvCxnSpPr/>
           <p:nvPr/>
         </p:nvCxnSpPr>
         <p:spPr>
-          <a:xfrm flipV="1">
-            <a:off x="2926080" y="3291840"/>
-            <a:ext cx="502920" cy="1508760"/>
+          <a:xfrm>
+            <a:off x="2606040" y="4754880"/>
+            <a:ext cx="228600" cy="0"/>
           </a:xfrm>
           <a:prstGeom prst="line">
             <a:avLst/>
@@ -12597,47 +12988,14 @@
       </p:cxnSp>
       <p:sp>
         <p:nvSpPr>
-          <p:cNvPr id="17" name="TextBox 16"/>
-          <p:cNvSpPr txBox="1"/>
-          <p:nvPr/>
-        </p:nvSpPr>
-        <p:spPr>
-          <a:xfrm>
-            <a:off x="3429000" y="1097280"/>
-            <a:ext cx="2194560" cy="274320"/>
-          </a:xfrm>
-          <a:prstGeom prst="rect">
-            <a:avLst/>
-          </a:prstGeom>
-          <a:noFill/>
-        </p:spPr>
-        <p:txBody>
-          <a:bodyPr wrap="square" anchor="t" lIns="0" rIns="0" tIns="0" bIns="0">
-            <a:spAutoFit/>
-          </a:bodyPr>
-          <a:lstStyle/>
-          <a:p>
-            <a:r>
-              <a:rPr sz="1100" b="1" i="0">
-                <a:solidFill>
-                  <a:srgbClr val="6B7785"/>
-                </a:solidFill>
-              </a:rPr>
-              <a:t>STORAGE</a:t>
-            </a:r>
-          </a:p>
-        </p:txBody>
-      </p:sp>
-      <p:sp>
-        <p:nvSpPr>
-          <p:cNvPr id="18" name="Rectangle 17"/>
+          <p:cNvPr id="28" name="Rectangle 27"/>
           <p:cNvSpPr/>
           <p:nvPr/>
         </p:nvSpPr>
         <p:spPr>
           <a:xfrm>
-            <a:off x="3429000" y="1371600"/>
-            <a:ext cx="2194560" cy="3840480"/>
+            <a:off x="4526280" y="1463040"/>
+            <a:ext cx="1737360" cy="3566160"/>
           </a:xfrm>
           <a:prstGeom prst="rect">
             <a:avLst/>
@@ -12674,14 +13032,92 @@
       </p:sp>
       <p:sp>
         <p:nvSpPr>
-          <p:cNvPr id="19" name="TextBox 18"/>
+          <p:cNvPr id="29" name="TextBox 28"/>
           <p:cNvSpPr txBox="1"/>
           <p:nvPr/>
         </p:nvSpPr>
         <p:spPr>
           <a:xfrm>
-            <a:off x="3483864" y="1371600"/>
-            <a:ext cx="2084831" cy="3840480"/>
+            <a:off x="4572000" y="1508760"/>
+            <a:ext cx="1645920" cy="320040"/>
+          </a:xfrm>
+          <a:prstGeom prst="rect">
+            <a:avLst/>
+          </a:prstGeom>
+          <a:noFill/>
+        </p:spPr>
+        <p:txBody>
+          <a:bodyPr wrap="square" anchor="t" lIns="0" rIns="0" tIns="0" bIns="0">
+            <a:spAutoFit/>
+          </a:bodyPr>
+          <a:lstStyle/>
+          <a:p>
+            <a:pPr algn="ctr"/>
+            <a:r>
+              <a:rPr sz="1300" b="1" i="0">
+                <a:solidFill>
+                  <a:srgbClr val="FFFFFF"/>
+                </a:solidFill>
+              </a:rPr>
+              <a:t>HDFS lakehouse</a:t>
+            </a:r>
+          </a:p>
+        </p:txBody>
+      </p:sp>
+      <p:sp>
+        <p:nvSpPr>
+          <p:cNvPr id="30" name="Rectangle 29"/>
+          <p:cNvSpPr/>
+          <p:nvPr/>
+        </p:nvSpPr>
+        <p:spPr>
+          <a:xfrm>
+            <a:off x="4617720" y="1920240"/>
+            <a:ext cx="1554480" cy="365760"/>
+          </a:xfrm>
+          <a:prstGeom prst="rect">
+            <a:avLst/>
+          </a:prstGeom>
+          <a:solidFill>
+            <a:srgbClr val="2A7FAE"/>
+          </a:solidFill>
+          <a:ln>
+            <a:noFill/>
+          </a:ln>
+          <a:effectLst/>
+        </p:spPr>
+        <p:style>
+          <a:lnRef idx="1">
+            <a:schemeClr val="accent1"/>
+          </a:lnRef>
+          <a:fillRef idx="3">
+            <a:schemeClr val="accent1"/>
+          </a:fillRef>
+          <a:effectRef idx="2">
+            <a:schemeClr val="accent1"/>
+          </a:effectRef>
+          <a:fontRef idx="minor">
+            <a:schemeClr val="lt1"/>
+          </a:fontRef>
+        </p:style>
+        <p:txBody>
+          <a:bodyPr rtlCol="0" anchor="ctr"/>
+          <a:lstStyle/>
+          <a:p>
+            <a:pPr algn="ctr"/>
+          </a:p>
+        </p:txBody>
+      </p:sp>
+      <p:sp>
+        <p:nvSpPr>
+          <p:cNvPr id="31" name="TextBox 30"/>
+          <p:cNvSpPr txBox="1"/>
+          <p:nvPr/>
+        </p:nvSpPr>
+        <p:spPr>
+          <a:xfrm>
+            <a:off x="4663440" y="1920240"/>
+            <a:ext cx="1463039" cy="365760"/>
           </a:xfrm>
           <a:prstGeom prst="rect">
             <a:avLst/>
@@ -12696,114 +13132,451 @@
           <a:p>
             <a:pPr algn="ctr"/>
             <a:r>
-              <a:rPr sz="1300" b="1" i="0">
+              <a:rPr sz="950" b="0" i="0">
                 <a:solidFill>
                   <a:srgbClr val="FFFFFF"/>
                 </a:solidFill>
               </a:rPr>
-              <a:t>HDFS lakehouse</a:t>
-            </a:r>
-          </a:p>
+              <a:t>raw (CSV / JSON)</a:t>
+            </a:r>
+          </a:p>
+        </p:txBody>
+      </p:sp>
+      <p:sp>
+        <p:nvSpPr>
+          <p:cNvPr id="32" name="Rectangle 31"/>
+          <p:cNvSpPr/>
+          <p:nvPr/>
+        </p:nvSpPr>
+        <p:spPr>
+          <a:xfrm>
+            <a:off x="4617720" y="2377440"/>
+            <a:ext cx="1554480" cy="365760"/>
+          </a:xfrm>
+          <a:prstGeom prst="rect">
+            <a:avLst/>
+          </a:prstGeom>
+          <a:solidFill>
+            <a:srgbClr val="2A7FAE"/>
+          </a:solidFill>
+          <a:ln>
+            <a:noFill/>
+          </a:ln>
+          <a:effectLst/>
+        </p:spPr>
+        <p:style>
+          <a:lnRef idx="1">
+            <a:schemeClr val="accent1"/>
+          </a:lnRef>
+          <a:fillRef idx="3">
+            <a:schemeClr val="accent1"/>
+          </a:fillRef>
+          <a:effectRef idx="2">
+            <a:schemeClr val="accent1"/>
+          </a:effectRef>
+          <a:fontRef idx="minor">
+            <a:schemeClr val="lt1"/>
+          </a:fontRef>
+        </p:style>
+        <p:txBody>
+          <a:bodyPr rtlCol="0" anchor="ctr"/>
+          <a:lstStyle/>
           <a:p>
             <a:pPr algn="ctr"/>
-            <a:r>
-              <a:rPr sz="1300" b="1" i="0">
+          </a:p>
+        </p:txBody>
+      </p:sp>
+      <p:sp>
+        <p:nvSpPr>
+          <p:cNvPr id="33" name="TextBox 32"/>
+          <p:cNvSpPr txBox="1"/>
+          <p:nvPr/>
+        </p:nvSpPr>
+        <p:spPr>
+          <a:xfrm>
+            <a:off x="4663440" y="2377440"/>
+            <a:ext cx="1463039" cy="365760"/>
+          </a:xfrm>
+          <a:prstGeom prst="rect">
+            <a:avLst/>
+          </a:prstGeom>
+          <a:noFill/>
+        </p:spPr>
+        <p:txBody>
+          <a:bodyPr wrap="square" anchor="ctr" lIns="0" rIns="0" tIns="0" bIns="0">
+            <a:spAutoFit/>
+          </a:bodyPr>
+          <a:lstStyle/>
+          <a:p>
+            <a:pPr algn="ctr"/>
+            <a:r>
+              <a:rPr sz="950" b="0" i="0">
                 <a:solidFill>
                   <a:srgbClr val="FFFFFF"/>
                 </a:solidFill>
               </a:rPr>
-              <a:t/>
-            </a:r>
-          </a:p>
+              <a:t>clean (Parquet, by city)</a:t>
+            </a:r>
+          </a:p>
+        </p:txBody>
+      </p:sp>
+      <p:sp>
+        <p:nvSpPr>
+          <p:cNvPr id="34" name="Rectangle 33"/>
+          <p:cNvSpPr/>
+          <p:nvPr/>
+        </p:nvSpPr>
+        <p:spPr>
+          <a:xfrm>
+            <a:off x="4617720" y="2834640"/>
+            <a:ext cx="1554480" cy="365760"/>
+          </a:xfrm>
+          <a:prstGeom prst="rect">
+            <a:avLst/>
+          </a:prstGeom>
+          <a:solidFill>
+            <a:srgbClr val="2A7FAE"/>
+          </a:solidFill>
+          <a:ln>
+            <a:noFill/>
+          </a:ln>
+          <a:effectLst/>
+        </p:spPr>
+        <p:style>
+          <a:lnRef idx="1">
+            <a:schemeClr val="accent1"/>
+          </a:lnRef>
+          <a:fillRef idx="3">
+            <a:schemeClr val="accent1"/>
+          </a:fillRef>
+          <a:effectRef idx="2">
+            <a:schemeClr val="accent1"/>
+          </a:effectRef>
+          <a:fontRef idx="minor">
+            <a:schemeClr val="lt1"/>
+          </a:fontRef>
+        </p:style>
+        <p:txBody>
+          <a:bodyPr rtlCol="0" anchor="ctr"/>
+          <a:lstStyle/>
           <a:p>
             <a:pPr algn="ctr"/>
-            <a:r>
-              <a:rPr sz="1300" b="1" i="0">
+          </a:p>
+        </p:txBody>
+      </p:sp>
+      <p:sp>
+        <p:nvSpPr>
+          <p:cNvPr id="35" name="TextBox 34"/>
+          <p:cNvSpPr txBox="1"/>
+          <p:nvPr/>
+        </p:nvSpPr>
+        <p:spPr>
+          <a:xfrm>
+            <a:off x="4663440" y="2834640"/>
+            <a:ext cx="1463039" cy="365760"/>
+          </a:xfrm>
+          <a:prstGeom prst="rect">
+            <a:avLst/>
+          </a:prstGeom>
+          <a:noFill/>
+        </p:spPr>
+        <p:txBody>
+          <a:bodyPr wrap="square" anchor="ctr" lIns="0" rIns="0" tIns="0" bIns="0">
+            <a:spAutoFit/>
+          </a:bodyPr>
+          <a:lstStyle/>
+          <a:p>
+            <a:pPr algn="ctr"/>
+            <a:r>
+              <a:rPr sz="950" b="0" i="0">
                 <a:solidFill>
                   <a:srgbClr val="FFFFFF"/>
                 </a:solidFill>
               </a:rPr>
-              <a:t>1 NameNode</a:t>
-            </a:r>
-          </a:p>
+              <a:t>features (86-dim)</a:t>
+            </a:r>
+          </a:p>
+        </p:txBody>
+      </p:sp>
+      <p:sp>
+        <p:nvSpPr>
+          <p:cNvPr id="36" name="Rectangle 35"/>
+          <p:cNvSpPr/>
+          <p:nvPr/>
+        </p:nvSpPr>
+        <p:spPr>
+          <a:xfrm>
+            <a:off x="4617720" y="3291840"/>
+            <a:ext cx="1554480" cy="365760"/>
+          </a:xfrm>
+          <a:prstGeom prst="rect">
+            <a:avLst/>
+          </a:prstGeom>
+          <a:solidFill>
+            <a:srgbClr val="2A7FAE"/>
+          </a:solidFill>
+          <a:ln>
+            <a:noFill/>
+          </a:ln>
+          <a:effectLst/>
+        </p:spPr>
+        <p:style>
+          <a:lnRef idx="1">
+            <a:schemeClr val="accent1"/>
+          </a:lnRef>
+          <a:fillRef idx="3">
+            <a:schemeClr val="accent1"/>
+          </a:fillRef>
+          <a:effectRef idx="2">
+            <a:schemeClr val="accent1"/>
+          </a:effectRef>
+          <a:fontRef idx="minor">
+            <a:schemeClr val="lt1"/>
+          </a:fontRef>
+        </p:style>
+        <p:txBody>
+          <a:bodyPr rtlCol="0" anchor="ctr"/>
+          <a:lstStyle/>
           <a:p>
             <a:pPr algn="ctr"/>
-            <a:r>
-              <a:rPr sz="1300" b="1" i="0">
+          </a:p>
+        </p:txBody>
+      </p:sp>
+      <p:sp>
+        <p:nvSpPr>
+          <p:cNvPr id="37" name="TextBox 36"/>
+          <p:cNvSpPr txBox="1"/>
+          <p:nvPr/>
+        </p:nvSpPr>
+        <p:spPr>
+          <a:xfrm>
+            <a:off x="4663440" y="3291840"/>
+            <a:ext cx="1463039" cy="365760"/>
+          </a:xfrm>
+          <a:prstGeom prst="rect">
+            <a:avLst/>
+          </a:prstGeom>
+          <a:noFill/>
+        </p:spPr>
+        <p:txBody>
+          <a:bodyPr wrap="square" anchor="ctr" lIns="0" rIns="0" tIns="0" bIns="0">
+            <a:spAutoFit/>
+          </a:bodyPr>
+          <a:lstStyle/>
+          <a:p>
+            <a:pPr algn="ctr"/>
+            <a:r>
+              <a:rPr sz="950" b="0" i="0">
                 <a:solidFill>
                   <a:srgbClr val="FFFFFF"/>
                 </a:solidFill>
               </a:rPr>
-              <a:t>4 DataNodes</a:t>
-            </a:r>
-          </a:p>
+              <a:t>unified table</a:t>
+            </a:r>
+          </a:p>
+        </p:txBody>
+      </p:sp>
+      <p:sp>
+        <p:nvSpPr>
+          <p:cNvPr id="38" name="Rectangle 37"/>
+          <p:cNvSpPr/>
+          <p:nvPr/>
+        </p:nvSpPr>
+        <p:spPr>
+          <a:xfrm>
+            <a:off x="4617720" y="3749039"/>
+            <a:ext cx="1554480" cy="365760"/>
+          </a:xfrm>
+          <a:prstGeom prst="rect">
+            <a:avLst/>
+          </a:prstGeom>
+          <a:solidFill>
+            <a:srgbClr val="2A7FAE"/>
+          </a:solidFill>
+          <a:ln>
+            <a:noFill/>
+          </a:ln>
+          <a:effectLst/>
+        </p:spPr>
+        <p:style>
+          <a:lnRef idx="1">
+            <a:schemeClr val="accent1"/>
+          </a:lnRef>
+          <a:fillRef idx="3">
+            <a:schemeClr val="accent1"/>
+          </a:fillRef>
+          <a:effectRef idx="2">
+            <a:schemeClr val="accent1"/>
+          </a:effectRef>
+          <a:fontRef idx="minor">
+            <a:schemeClr val="lt1"/>
+          </a:fontRef>
+        </p:style>
+        <p:txBody>
+          <a:bodyPr rtlCol="0" anchor="ctr"/>
+          <a:lstStyle/>
           <a:p>
             <a:pPr algn="ctr"/>
-            <a:r>
-              <a:rPr sz="1300" b="1" i="0">
+          </a:p>
+        </p:txBody>
+      </p:sp>
+      <p:sp>
+        <p:nvSpPr>
+          <p:cNvPr id="39" name="TextBox 38"/>
+          <p:cNvSpPr txBox="1"/>
+          <p:nvPr/>
+        </p:nvSpPr>
+        <p:spPr>
+          <a:xfrm>
+            <a:off x="4663440" y="3749039"/>
+            <a:ext cx="1463039" cy="365760"/>
+          </a:xfrm>
+          <a:prstGeom prst="rect">
+            <a:avLst/>
+          </a:prstGeom>
+          <a:noFill/>
+        </p:spPr>
+        <p:txBody>
+          <a:bodyPr wrap="square" anchor="ctr" lIns="0" rIns="0" tIns="0" bIns="0">
+            <a:spAutoFit/>
+          </a:bodyPr>
+          <a:lstStyle/>
+          <a:p>
+            <a:pPr algn="ctr"/>
+            <a:r>
+              <a:rPr sz="950" b="0" i="0">
                 <a:solidFill>
                   <a:srgbClr val="FFFFFF"/>
                 </a:solidFill>
               </a:rPr>
-              <a:t>128 MB blocks</a:t>
-            </a:r>
-          </a:p>
+              <a:t>stream: input · history</a:t>
+            </a:r>
+          </a:p>
+        </p:txBody>
+      </p:sp>
+      <p:sp>
+        <p:nvSpPr>
+          <p:cNvPr id="40" name="Rectangle 39"/>
+          <p:cNvSpPr/>
+          <p:nvPr/>
+        </p:nvSpPr>
+        <p:spPr>
+          <a:xfrm>
+            <a:off x="4617720" y="4206240"/>
+            <a:ext cx="1554480" cy="365760"/>
+          </a:xfrm>
+          <a:prstGeom prst="rect">
+            <a:avLst/>
+          </a:prstGeom>
+          <a:solidFill>
+            <a:srgbClr val="2A7FAE"/>
+          </a:solidFill>
+          <a:ln>
+            <a:noFill/>
+          </a:ln>
+          <a:effectLst/>
+        </p:spPr>
+        <p:style>
+          <a:lnRef idx="1">
+            <a:schemeClr val="accent1"/>
+          </a:lnRef>
+          <a:fillRef idx="3">
+            <a:schemeClr val="accent1"/>
+          </a:fillRef>
+          <a:effectRef idx="2">
+            <a:schemeClr val="accent1"/>
+          </a:effectRef>
+          <a:fontRef idx="minor">
+            <a:schemeClr val="lt1"/>
+          </a:fontRef>
+        </p:style>
+        <p:txBody>
+          <a:bodyPr rtlCol="0" anchor="ctr"/>
+          <a:lstStyle/>
           <a:p>
             <a:pPr algn="ctr"/>
-            <a:r>
-              <a:rPr sz="1300" b="1" i="0">
+          </a:p>
+        </p:txBody>
+      </p:sp>
+      <p:sp>
+        <p:nvSpPr>
+          <p:cNvPr id="41" name="TextBox 40"/>
+          <p:cNvSpPr txBox="1"/>
+          <p:nvPr/>
+        </p:nvSpPr>
+        <p:spPr>
+          <a:xfrm>
+            <a:off x="4663440" y="4206240"/>
+            <a:ext cx="1463039" cy="365760"/>
+          </a:xfrm>
+          <a:prstGeom prst="rect">
+            <a:avLst/>
+          </a:prstGeom>
+          <a:noFill/>
+        </p:spPr>
+        <p:txBody>
+          <a:bodyPr wrap="square" anchor="ctr" lIns="0" rIns="0" tIns="0" bIns="0">
+            <a:spAutoFit/>
+          </a:bodyPr>
+          <a:lstStyle/>
+          <a:p>
+            <a:pPr algn="ctr"/>
+            <a:r>
+              <a:rPr sz="950" b="0" i="0">
                 <a:solidFill>
                   <a:srgbClr val="FFFFFF"/>
                 </a:solidFill>
               </a:rPr>
-              <a:t>3× replication</a:t>
-            </a:r>
-          </a:p>
+              <a:t>models: GBT + pipeline</a:t>
+            </a:r>
+          </a:p>
+        </p:txBody>
+      </p:sp>
+      <p:sp>
+        <p:nvSpPr>
+          <p:cNvPr id="42" name="TextBox 41"/>
+          <p:cNvSpPr txBox="1"/>
+          <p:nvPr/>
+        </p:nvSpPr>
+        <p:spPr>
+          <a:xfrm>
+            <a:off x="4572000" y="4663440"/>
+            <a:ext cx="1645920" cy="365760"/>
+          </a:xfrm>
+          <a:prstGeom prst="rect">
+            <a:avLst/>
+          </a:prstGeom>
+          <a:noFill/>
+        </p:spPr>
+        <p:txBody>
+          <a:bodyPr wrap="square" anchor="t" lIns="0" rIns="0" tIns="0" bIns="0">
+            <a:spAutoFit/>
+          </a:bodyPr>
+          <a:lstStyle/>
           <a:p>
             <a:pPr algn="ctr"/>
             <a:r>
-              <a:rPr sz="1300" b="1" i="0">
-                <a:solidFill>
-                  <a:srgbClr val="FFFFFF"/>
-                </a:solidFill>
-              </a:rPr>
-              <a:t/>
-            </a:r>
-          </a:p>
-          <a:p>
-            <a:pPr algn="ctr"/>
-            <a:r>
-              <a:rPr sz="1300" b="1" i="0">
-                <a:solidFill>
-                  <a:srgbClr val="FFFFFF"/>
-                </a:solidFill>
-              </a:rPr>
-              <a:t>raw → clean → features</a:t>
-            </a:r>
-          </a:p>
-          <a:p>
-            <a:pPr algn="ctr"/>
-            <a:r>
-              <a:rPr sz="1300" b="1" i="0">
-                <a:solidFill>
-                  <a:srgbClr val="FFFFFF"/>
-                </a:solidFill>
-              </a:rPr>
-              <a:t>→ unified → stream</a:t>
+              <a:rPr sz="950" b="0" i="0">
+                <a:solidFill>
+                  <a:srgbClr val="DCEBF4"/>
+                </a:solidFill>
+              </a:rPr>
+              <a:t>1 NN + 4 DN
+128 MB · 3×</a:t>
             </a:r>
           </a:p>
         </p:txBody>
       </p:sp>
       <p:cxnSp>
         <p:nvCxnSpPr>
-          <p:cNvPr id="20" name="Connector 19"/>
+          <p:cNvPr id="43" name="Connector 42"/>
           <p:cNvCxnSpPr/>
           <p:nvPr/>
         </p:nvCxnSpPr>
         <p:spPr>
           <a:xfrm>
-            <a:off x="5623560" y="3291840"/>
-            <a:ext cx="548640" cy="0"/>
+            <a:off x="4297680" y="3246120"/>
+            <a:ext cx="228600" cy="0"/>
           </a:xfrm>
           <a:prstGeom prst="line">
             <a:avLst/>
@@ -12832,14 +13605,60 @@
       </p:cxnSp>
       <p:sp>
         <p:nvSpPr>
-          <p:cNvPr id="21" name="TextBox 20"/>
+          <p:cNvPr id="44" name="Rectangle 43"/>
+          <p:cNvSpPr/>
+          <p:nvPr/>
+        </p:nvSpPr>
+        <p:spPr>
+          <a:xfrm>
+            <a:off x="6492240" y="1463040"/>
+            <a:ext cx="3794760" cy="3566160"/>
+          </a:xfrm>
+          <a:prstGeom prst="rect">
+            <a:avLst/>
+          </a:prstGeom>
+          <a:solidFill>
+            <a:srgbClr val="E9F1F6"/>
+          </a:solidFill>
+          <a:ln w="6350">
+            <a:solidFill>
+              <a:srgbClr val="0B5F8A"/>
+            </a:solidFill>
+          </a:ln>
+          <a:effectLst/>
+        </p:spPr>
+        <p:style>
+          <a:lnRef idx="1">
+            <a:schemeClr val="accent1"/>
+          </a:lnRef>
+          <a:fillRef idx="3">
+            <a:schemeClr val="accent1"/>
+          </a:fillRef>
+          <a:effectRef idx="2">
+            <a:schemeClr val="accent1"/>
+          </a:effectRef>
+          <a:fontRef idx="minor">
+            <a:schemeClr val="lt1"/>
+          </a:fontRef>
+        </p:style>
+        <p:txBody>
+          <a:bodyPr rtlCol="0" anchor="ctr"/>
+          <a:lstStyle/>
+          <a:p>
+            <a:pPr algn="ctr"/>
+          </a:p>
+        </p:txBody>
+      </p:sp>
+      <p:sp>
+        <p:nvSpPr>
+          <p:cNvPr id="45" name="TextBox 44"/>
           <p:cNvSpPr txBox="1"/>
           <p:nvPr/>
         </p:nvSpPr>
         <p:spPr>
           <a:xfrm>
-            <a:off x="6172200" y="1097280"/>
-            <a:ext cx="3657600" cy="274320"/>
+            <a:off x="6583680" y="1508760"/>
+            <a:ext cx="3611880" cy="274320"/>
           </a:xfrm>
           <a:prstGeom prst="rect">
             <a:avLst/>
@@ -12855,30 +13674,1483 @@
             <a:r>
               <a:rPr sz="1100" b="1" i="0">
                 <a:solidFill>
+                  <a:srgbClr val="0B5F8A"/>
+                </a:solidFill>
+              </a:rPr>
+              <a:t>Apache Spark 3.5.6 on YARN  (1 RM + 4 NM)</a:t>
+            </a:r>
+          </a:p>
+        </p:txBody>
+      </p:sp>
+      <p:sp>
+        <p:nvSpPr>
+          <p:cNvPr id="46" name="TextBox 45"/>
+          <p:cNvSpPr txBox="1"/>
+          <p:nvPr/>
+        </p:nvSpPr>
+        <p:spPr>
+          <a:xfrm>
+            <a:off x="6583680" y="1874519"/>
+            <a:ext cx="3611880" cy="228600"/>
+          </a:xfrm>
+          <a:prstGeom prst="rect">
+            <a:avLst/>
+          </a:prstGeom>
+          <a:noFill/>
+        </p:spPr>
+        <p:txBody>
+          <a:bodyPr wrap="square" anchor="t" lIns="0" rIns="0" tIns="0" bIns="0">
+            <a:spAutoFit/>
+          </a:bodyPr>
+          <a:lstStyle/>
+          <a:p>
+            <a:r>
+              <a:rPr sz="950" b="1" i="0">
+                <a:solidFill>
                   <a:srgbClr val="6B7785"/>
                 </a:solidFill>
               </a:rPr>
-              <a:t>SPARK CLUSTER (YARN: 1 RM + 4 NM)</a:t>
-            </a:r>
-          </a:p>
-        </p:txBody>
-      </p:sp>
-      <p:sp>
-        <p:nvSpPr>
-          <p:cNvPr id="22" name="Rectangle 21"/>
+              <a:t>BATCH LAYER — trains on 13 years of history</a:t>
+            </a:r>
+          </a:p>
+        </p:txBody>
+      </p:sp>
+      <p:sp>
+        <p:nvSpPr>
+          <p:cNvPr id="47" name="Rectangle 46"/>
           <p:cNvSpPr/>
           <p:nvPr/>
         </p:nvSpPr>
         <p:spPr>
           <a:xfrm>
-            <a:off x="6172200" y="1371600"/>
-            <a:ext cx="3566160" cy="3840480"/>
+            <a:off x="6629400" y="2148840"/>
+            <a:ext cx="1051560" cy="777240"/>
           </a:xfrm>
           <a:prstGeom prst="rect">
             <a:avLst/>
           </a:prstGeom>
           <a:solidFill>
-            <a:srgbClr val="E9F1F6"/>
+            <a:srgbClr val="DCEBF4"/>
+          </a:solidFill>
+          <a:ln>
+            <a:noFill/>
+          </a:ln>
+          <a:effectLst/>
+        </p:spPr>
+        <p:style>
+          <a:lnRef idx="1">
+            <a:schemeClr val="accent1"/>
+          </a:lnRef>
+          <a:fillRef idx="3">
+            <a:schemeClr val="accent1"/>
+          </a:fillRef>
+          <a:effectRef idx="2">
+            <a:schemeClr val="accent1"/>
+          </a:effectRef>
+          <a:fontRef idx="minor">
+            <a:schemeClr val="lt1"/>
+          </a:fontRef>
+        </p:style>
+        <p:txBody>
+          <a:bodyPr rtlCol="0" anchor="ctr"/>
+          <a:lstStyle/>
+          <a:p>
+            <a:pPr algn="ctr"/>
+          </a:p>
+        </p:txBody>
+      </p:sp>
+      <p:sp>
+        <p:nvSpPr>
+          <p:cNvPr id="48" name="TextBox 47"/>
+          <p:cNvSpPr txBox="1"/>
+          <p:nvPr/>
+        </p:nvSpPr>
+        <p:spPr>
+          <a:xfrm>
+            <a:off x="6675120" y="2148840"/>
+            <a:ext cx="960119" cy="777240"/>
+          </a:xfrm>
+          <a:prstGeom prst="rect">
+            <a:avLst/>
+          </a:prstGeom>
+          <a:noFill/>
+        </p:spPr>
+        <p:txBody>
+          <a:bodyPr wrap="square" anchor="ctr" lIns="0" rIns="0" tIns="0" bIns="0">
+            <a:spAutoFit/>
+          </a:bodyPr>
+          <a:lstStyle/>
+          <a:p>
+            <a:pPr algn="ctr"/>
+            <a:r>
+              <a:rPr sz="950" b="1" i="0">
+                <a:solidFill>
+                  <a:srgbClr val="1A1A1A"/>
+                </a:solidFill>
+              </a:rPr>
+              <a:t>CleanSelect</a:t>
+            </a:r>
+          </a:p>
+          <a:p>
+            <a:pPr algn="ctr"/>
+            <a:r>
+              <a:rPr sz="950" b="1" i="0">
+                <a:solidFill>
+                  <a:srgbClr val="1A1A1A"/>
+                </a:solidFill>
+              </a:rPr>
+              <a:t>(Scala)</a:t>
+            </a:r>
+          </a:p>
+          <a:p>
+            <a:pPr algn="ctr"/>
+            <a:r>
+              <a:rPr sz="950" b="1" i="0">
+                <a:solidFill>
+                  <a:srgbClr val="1A1A1A"/>
+                </a:solidFill>
+              </a:rPr>
+              <a:t>clean + impute</a:t>
+            </a:r>
+          </a:p>
+        </p:txBody>
+      </p:sp>
+      <p:sp>
+        <p:nvSpPr>
+          <p:cNvPr id="49" name="Rectangle 48"/>
+          <p:cNvSpPr/>
+          <p:nvPr/>
+        </p:nvSpPr>
+        <p:spPr>
+          <a:xfrm>
+            <a:off x="7909560" y="2148840"/>
+            <a:ext cx="1051560" cy="777240"/>
+          </a:xfrm>
+          <a:prstGeom prst="rect">
+            <a:avLst/>
+          </a:prstGeom>
+          <a:solidFill>
+            <a:srgbClr val="DCEBF4"/>
+          </a:solidFill>
+          <a:ln>
+            <a:noFill/>
+          </a:ln>
+          <a:effectLst/>
+        </p:spPr>
+        <p:style>
+          <a:lnRef idx="1">
+            <a:schemeClr val="accent1"/>
+          </a:lnRef>
+          <a:fillRef idx="3">
+            <a:schemeClr val="accent1"/>
+          </a:fillRef>
+          <a:effectRef idx="2">
+            <a:schemeClr val="accent1"/>
+          </a:effectRef>
+          <a:fontRef idx="minor">
+            <a:schemeClr val="lt1"/>
+          </a:fontRef>
+        </p:style>
+        <p:txBody>
+          <a:bodyPr rtlCol="0" anchor="ctr"/>
+          <a:lstStyle/>
+          <a:p>
+            <a:pPr algn="ctr"/>
+          </a:p>
+        </p:txBody>
+      </p:sp>
+      <p:sp>
+        <p:nvSpPr>
+          <p:cNvPr id="50" name="TextBox 49"/>
+          <p:cNvSpPr txBox="1"/>
+          <p:nvPr/>
+        </p:nvSpPr>
+        <p:spPr>
+          <a:xfrm>
+            <a:off x="7955280" y="2148840"/>
+            <a:ext cx="960119" cy="777240"/>
+          </a:xfrm>
+          <a:prstGeom prst="rect">
+            <a:avLst/>
+          </a:prstGeom>
+          <a:noFill/>
+        </p:spPr>
+        <p:txBody>
+          <a:bodyPr wrap="square" anchor="ctr" lIns="0" rIns="0" tIns="0" bIns="0">
+            <a:spAutoFit/>
+          </a:bodyPr>
+          <a:lstStyle/>
+          <a:p>
+            <a:pPr algn="ctr"/>
+            <a:r>
+              <a:rPr sz="950" b="1" i="0">
+                <a:solidFill>
+                  <a:srgbClr val="1A1A1A"/>
+                </a:solidFill>
+              </a:rPr>
+              <a:t>Feature-</a:t>
+            </a:r>
+          </a:p>
+          <a:p>
+            <a:pPr algn="ctr"/>
+            <a:r>
+              <a:rPr sz="950" b="1" i="0">
+                <a:solidFill>
+                  <a:srgbClr val="1A1A1A"/>
+                </a:solidFill>
+              </a:rPr>
+              <a:t>Extraction</a:t>
+            </a:r>
+          </a:p>
+          <a:p>
+            <a:pPr algn="ctr"/>
+            <a:r>
+              <a:rPr sz="950" b="1" i="0">
+                <a:solidFill>
+                  <a:srgbClr val="1A1A1A"/>
+                </a:solidFill>
+              </a:rPr>
+              <a:t>(Scala) 86 feat.</a:t>
+            </a:r>
+          </a:p>
+        </p:txBody>
+      </p:sp>
+      <p:sp>
+        <p:nvSpPr>
+          <p:cNvPr id="51" name="Rectangle 50"/>
+          <p:cNvSpPr/>
+          <p:nvPr/>
+        </p:nvSpPr>
+        <p:spPr>
+          <a:xfrm>
+            <a:off x="9189720" y="2148840"/>
+            <a:ext cx="1005840" cy="777240"/>
+          </a:xfrm>
+          <a:prstGeom prst="rect">
+            <a:avLst/>
+          </a:prstGeom>
+          <a:solidFill>
+            <a:srgbClr val="7A1B2E"/>
+          </a:solidFill>
+          <a:ln>
+            <a:noFill/>
+          </a:ln>
+          <a:effectLst/>
+        </p:spPr>
+        <p:style>
+          <a:lnRef idx="1">
+            <a:schemeClr val="accent1"/>
+          </a:lnRef>
+          <a:fillRef idx="3">
+            <a:schemeClr val="accent1"/>
+          </a:fillRef>
+          <a:effectRef idx="2">
+            <a:schemeClr val="accent1"/>
+          </a:effectRef>
+          <a:fontRef idx="minor">
+            <a:schemeClr val="lt1"/>
+          </a:fontRef>
+        </p:style>
+        <p:txBody>
+          <a:bodyPr rtlCol="0" anchor="ctr"/>
+          <a:lstStyle/>
+          <a:p>
+            <a:pPr algn="ctr"/>
+          </a:p>
+        </p:txBody>
+      </p:sp>
+      <p:sp>
+        <p:nvSpPr>
+          <p:cNvPr id="52" name="TextBox 51"/>
+          <p:cNvSpPr txBox="1"/>
+          <p:nvPr/>
+        </p:nvSpPr>
+        <p:spPr>
+          <a:xfrm>
+            <a:off x="9235440" y="2148840"/>
+            <a:ext cx="914400" cy="777240"/>
+          </a:xfrm>
+          <a:prstGeom prst="rect">
+            <a:avLst/>
+          </a:prstGeom>
+          <a:noFill/>
+        </p:spPr>
+        <p:txBody>
+          <a:bodyPr wrap="square" anchor="ctr" lIns="0" rIns="0" tIns="0" bIns="0">
+            <a:spAutoFit/>
+          </a:bodyPr>
+          <a:lstStyle/>
+          <a:p>
+            <a:pPr algn="ctr"/>
+            <a:r>
+              <a:rPr sz="950" b="1" i="0">
+                <a:solidFill>
+                  <a:srgbClr val="FFFFFF"/>
+                </a:solidFill>
+              </a:rPr>
+              <a:t>GBT training</a:t>
+            </a:r>
+          </a:p>
+          <a:p>
+            <a:pPr algn="ctr"/>
+            <a:r>
+              <a:rPr sz="950" b="1" i="0">
+                <a:solidFill>
+                  <a:srgbClr val="FFFFFF"/>
+                </a:solidFill>
+              </a:rPr>
+              <a:t>(PySpark MLlib)</a:t>
+            </a:r>
+          </a:p>
+          <a:p>
+            <a:pPr algn="ctr"/>
+            <a:r>
+              <a:rPr sz="950" b="1" i="0">
+                <a:solidFill>
+                  <a:srgbClr val="FFFFFF"/>
+                </a:solidFill>
+              </a:rPr>
+              <a:t>300 trees</a:t>
+            </a:r>
+          </a:p>
+        </p:txBody>
+      </p:sp>
+      <p:cxnSp>
+        <p:nvCxnSpPr>
+          <p:cNvPr id="53" name="Connector 52"/>
+          <p:cNvCxnSpPr/>
+          <p:nvPr/>
+        </p:nvCxnSpPr>
+        <p:spPr>
+          <a:xfrm>
+            <a:off x="7680960" y="2542032"/>
+            <a:ext cx="228600" cy="0"/>
+          </a:xfrm>
+          <a:prstGeom prst="line">
+            <a:avLst/>
+          </a:prstGeom>
+          <a:ln w="25400">
+            <a:solidFill>
+              <a:srgbClr val="6B7785"/>
+            </a:solidFill>
+            <a:tailEnd type="triangle"/>
+          </a:ln>
+        </p:spPr>
+        <p:style>
+          <a:lnRef idx="2">
+            <a:schemeClr val="accent1"/>
+          </a:lnRef>
+          <a:fillRef idx="0">
+            <a:schemeClr val="accent1"/>
+          </a:fillRef>
+          <a:effectRef idx="1">
+            <a:schemeClr val="accent1"/>
+          </a:effectRef>
+          <a:fontRef idx="minor">
+            <a:schemeClr val="tx1"/>
+          </a:fontRef>
+        </p:style>
+      </p:cxnSp>
+      <p:cxnSp>
+        <p:nvCxnSpPr>
+          <p:cNvPr id="54" name="Connector 53"/>
+          <p:cNvCxnSpPr/>
+          <p:nvPr/>
+        </p:nvCxnSpPr>
+        <p:spPr>
+          <a:xfrm>
+            <a:off x="8961120" y="2542032"/>
+            <a:ext cx="228600" cy="0"/>
+          </a:xfrm>
+          <a:prstGeom prst="line">
+            <a:avLst/>
+          </a:prstGeom>
+          <a:ln w="25400">
+            <a:solidFill>
+              <a:srgbClr val="6B7785"/>
+            </a:solidFill>
+            <a:tailEnd type="triangle"/>
+          </a:ln>
+        </p:spPr>
+        <p:style>
+          <a:lnRef idx="2">
+            <a:schemeClr val="accent1"/>
+          </a:lnRef>
+          <a:fillRef idx="0">
+            <a:schemeClr val="accent1"/>
+          </a:fillRef>
+          <a:effectRef idx="1">
+            <a:schemeClr val="accent1"/>
+          </a:effectRef>
+          <a:fontRef idx="minor">
+            <a:schemeClr val="tx1"/>
+          </a:fontRef>
+        </p:style>
+      </p:cxnSp>
+      <p:sp>
+        <p:nvSpPr>
+          <p:cNvPr id="55" name="Rectangle 54"/>
+          <p:cNvSpPr/>
+          <p:nvPr/>
+        </p:nvSpPr>
+        <p:spPr>
+          <a:xfrm>
+            <a:off x="6629400" y="3246120"/>
+            <a:ext cx="3566160" cy="18288"/>
+          </a:xfrm>
+          <a:prstGeom prst="rect">
+            <a:avLst/>
+          </a:prstGeom>
+          <a:solidFill>
+            <a:srgbClr val="D9DFE7"/>
+          </a:solidFill>
+          <a:ln>
+            <a:noFill/>
+          </a:ln>
+          <a:effectLst/>
+        </p:spPr>
+        <p:style>
+          <a:lnRef idx="1">
+            <a:schemeClr val="accent1"/>
+          </a:lnRef>
+          <a:fillRef idx="3">
+            <a:schemeClr val="accent1"/>
+          </a:fillRef>
+          <a:effectRef idx="2">
+            <a:schemeClr val="accent1"/>
+          </a:effectRef>
+          <a:fontRef idx="minor">
+            <a:schemeClr val="lt1"/>
+          </a:fontRef>
+        </p:style>
+        <p:txBody>
+          <a:bodyPr rtlCol="0" anchor="ctr"/>
+          <a:lstStyle/>
+          <a:p>
+            <a:pPr algn="ctr"/>
+          </a:p>
+        </p:txBody>
+      </p:sp>
+      <p:sp>
+        <p:nvSpPr>
+          <p:cNvPr id="56" name="TextBox 55"/>
+          <p:cNvSpPr txBox="1"/>
+          <p:nvPr/>
+        </p:nvSpPr>
+        <p:spPr>
+          <a:xfrm>
+            <a:off x="6583680" y="3310128"/>
+            <a:ext cx="3611880" cy="228600"/>
+          </a:xfrm>
+          <a:prstGeom prst="rect">
+            <a:avLst/>
+          </a:prstGeom>
+          <a:noFill/>
+        </p:spPr>
+        <p:txBody>
+          <a:bodyPr wrap="square" anchor="t" lIns="0" rIns="0" tIns="0" bIns="0">
+            <a:spAutoFit/>
+          </a:bodyPr>
+          <a:lstStyle/>
+          <a:p>
+            <a:r>
+              <a:rPr sz="950" b="1" i="0">
+                <a:solidFill>
+                  <a:srgbClr val="6B7785"/>
+                </a:solidFill>
+              </a:rPr>
+              <a:t>SPEED LAYER — scores live data every 10 s</a:t>
+            </a:r>
+          </a:p>
+        </p:txBody>
+      </p:sp>
+      <p:sp>
+        <p:nvSpPr>
+          <p:cNvPr id="57" name="Rectangle 56"/>
+          <p:cNvSpPr/>
+          <p:nvPr/>
+        </p:nvSpPr>
+        <p:spPr>
+          <a:xfrm>
+            <a:off x="6629400" y="3611880"/>
+            <a:ext cx="1371600" cy="868680"/>
+          </a:xfrm>
+          <a:prstGeom prst="rect">
+            <a:avLst/>
+          </a:prstGeom>
+          <a:solidFill>
+            <a:srgbClr val="D9EFF0"/>
+          </a:solidFill>
+          <a:ln>
+            <a:noFill/>
+          </a:ln>
+          <a:effectLst/>
+        </p:spPr>
+        <p:style>
+          <a:lnRef idx="1">
+            <a:schemeClr val="accent1"/>
+          </a:lnRef>
+          <a:fillRef idx="3">
+            <a:schemeClr val="accent1"/>
+          </a:fillRef>
+          <a:effectRef idx="2">
+            <a:schemeClr val="accent1"/>
+          </a:effectRef>
+          <a:fontRef idx="minor">
+            <a:schemeClr val="lt1"/>
+          </a:fontRef>
+        </p:style>
+        <p:txBody>
+          <a:bodyPr rtlCol="0" anchor="ctr"/>
+          <a:lstStyle/>
+          <a:p>
+            <a:pPr algn="ctr"/>
+          </a:p>
+        </p:txBody>
+      </p:sp>
+      <p:sp>
+        <p:nvSpPr>
+          <p:cNvPr id="58" name="TextBox 57"/>
+          <p:cNvSpPr txBox="1"/>
+          <p:nvPr/>
+        </p:nvSpPr>
+        <p:spPr>
+          <a:xfrm>
+            <a:off x="6675120" y="3611880"/>
+            <a:ext cx="1280160" cy="868680"/>
+          </a:xfrm>
+          <a:prstGeom prst="rect">
+            <a:avLst/>
+          </a:prstGeom>
+          <a:noFill/>
+        </p:spPr>
+        <p:txBody>
+          <a:bodyPr wrap="square" anchor="ctr" lIns="0" rIns="0" tIns="0" bIns="0">
+            <a:spAutoFit/>
+          </a:bodyPr>
+          <a:lstStyle/>
+          <a:p>
+            <a:pPr algn="ctr"/>
+            <a:r>
+              <a:rPr sz="950" b="1" i="0">
+                <a:solidFill>
+                  <a:srgbClr val="1A1A1A"/>
+                </a:solidFill>
+              </a:rPr>
+              <a:t>LiveEnrichment</a:t>
+            </a:r>
+          </a:p>
+          <a:p>
+            <a:pPr algn="ctr"/>
+            <a:r>
+              <a:rPr sz="950" b="1" i="0">
+                <a:solidFill>
+                  <a:srgbClr val="1A1A1A"/>
+                </a:solidFill>
+              </a:rPr>
+              <a:t>(Scala)</a:t>
+            </a:r>
+          </a:p>
+          <a:p>
+            <a:pPr algn="ctr"/>
+            <a:r>
+              <a:rPr sz="950" b="1" i="0">
+                <a:solidFill>
+                  <a:srgbClr val="1A1A1A"/>
+                </a:solidFill>
+              </a:rPr>
+              <a:t>CAMS+weather+profile</a:t>
+            </a:r>
+          </a:p>
+        </p:txBody>
+      </p:sp>
+      <p:sp>
+        <p:nvSpPr>
+          <p:cNvPr id="59" name="Rectangle 58"/>
+          <p:cNvSpPr/>
+          <p:nvPr/>
+        </p:nvSpPr>
+        <p:spPr>
+          <a:xfrm>
+            <a:off x="8321040" y="3611880"/>
+            <a:ext cx="1874519" cy="868680"/>
+          </a:xfrm>
+          <a:prstGeom prst="rect">
+            <a:avLst/>
+          </a:prstGeom>
+          <a:solidFill>
+            <a:srgbClr val="0E7C86"/>
+          </a:solidFill>
+          <a:ln>
+            <a:noFill/>
+          </a:ln>
+          <a:effectLst/>
+        </p:spPr>
+        <p:style>
+          <a:lnRef idx="1">
+            <a:schemeClr val="accent1"/>
+          </a:lnRef>
+          <a:fillRef idx="3">
+            <a:schemeClr val="accent1"/>
+          </a:fillRef>
+          <a:effectRef idx="2">
+            <a:schemeClr val="accent1"/>
+          </a:effectRef>
+          <a:fontRef idx="minor">
+            <a:schemeClr val="lt1"/>
+          </a:fontRef>
+        </p:style>
+        <p:txBody>
+          <a:bodyPr rtlCol="0" anchor="ctr"/>
+          <a:lstStyle/>
+          <a:p>
+            <a:pPr algn="ctr"/>
+          </a:p>
+        </p:txBody>
+      </p:sp>
+      <p:sp>
+        <p:nvSpPr>
+          <p:cNvPr id="60" name="TextBox 59"/>
+          <p:cNvSpPr txBox="1"/>
+          <p:nvPr/>
+        </p:nvSpPr>
+        <p:spPr>
+          <a:xfrm>
+            <a:off x="8366760" y="3611880"/>
+            <a:ext cx="1783079" cy="868680"/>
+          </a:xfrm>
+          <a:prstGeom prst="rect">
+            <a:avLst/>
+          </a:prstGeom>
+          <a:noFill/>
+        </p:spPr>
+        <p:txBody>
+          <a:bodyPr wrap="square" anchor="ctr" lIns="0" rIns="0" tIns="0" bIns="0">
+            <a:spAutoFit/>
+          </a:bodyPr>
+          <a:lstStyle/>
+          <a:p>
+            <a:pPr algn="ctr"/>
+            <a:r>
+              <a:rPr sz="950" b="1" i="0">
+                <a:solidFill>
+                  <a:srgbClr val="FFFFFF"/>
+                </a:solidFill>
+              </a:rPr>
+              <a:t>AirQualityStream (Scala)</a:t>
+            </a:r>
+          </a:p>
+          <a:p>
+            <a:pPr algn="ctr"/>
+            <a:r>
+              <a:rPr sz="950" b="1" i="0">
+                <a:solidFill>
+                  <a:srgbClr val="FFFFFF"/>
+                </a:solidFill>
+              </a:rPr>
+              <a:t>forBatch: features → GBT</a:t>
+            </a:r>
+          </a:p>
+          <a:p>
+            <a:pPr algn="ctr"/>
+            <a:r>
+              <a:rPr sz="950" b="1" i="0">
+                <a:solidFill>
+                  <a:srgbClr val="FFFFFF"/>
+                </a:solidFill>
+              </a:rPr>
+              <a:t>→ AQI → alerts</a:t>
+            </a:r>
+          </a:p>
+        </p:txBody>
+      </p:sp>
+      <p:cxnSp>
+        <p:nvCxnSpPr>
+          <p:cNvPr id="61" name="Connector 60"/>
+          <p:cNvCxnSpPr/>
+          <p:nvPr/>
+        </p:nvCxnSpPr>
+        <p:spPr>
+          <a:xfrm>
+            <a:off x="8001000" y="4041648"/>
+            <a:ext cx="320040" cy="0"/>
+          </a:xfrm>
+          <a:prstGeom prst="line">
+            <a:avLst/>
+          </a:prstGeom>
+          <a:ln w="25400">
+            <a:solidFill>
+              <a:srgbClr val="6B7785"/>
+            </a:solidFill>
+            <a:tailEnd type="triangle"/>
+          </a:ln>
+        </p:spPr>
+        <p:style>
+          <a:lnRef idx="2">
+            <a:schemeClr val="accent1"/>
+          </a:lnRef>
+          <a:fillRef idx="0">
+            <a:schemeClr val="accent1"/>
+          </a:fillRef>
+          <a:effectRef idx="1">
+            <a:schemeClr val="accent1"/>
+          </a:effectRef>
+          <a:fontRef idx="minor">
+            <a:schemeClr val="tx1"/>
+          </a:fontRef>
+        </p:style>
+      </p:cxnSp>
+      <p:cxnSp>
+        <p:nvCxnSpPr>
+          <p:cNvPr id="62" name="Connector 61"/>
+          <p:cNvCxnSpPr/>
+          <p:nvPr/>
+        </p:nvCxnSpPr>
+        <p:spPr>
+          <a:xfrm>
+            <a:off x="9692640" y="2926080"/>
+            <a:ext cx="0" cy="685800"/>
+          </a:xfrm>
+          <a:prstGeom prst="line">
+            <a:avLst/>
+          </a:prstGeom>
+          <a:ln w="27940">
+            <a:solidFill>
+              <a:srgbClr val="7A1B2E"/>
+            </a:solidFill>
+            <a:tailEnd type="triangle"/>
+          </a:ln>
+        </p:spPr>
+        <p:style>
+          <a:lnRef idx="2">
+            <a:schemeClr val="accent1"/>
+          </a:lnRef>
+          <a:fillRef idx="0">
+            <a:schemeClr val="accent1"/>
+          </a:fillRef>
+          <a:effectRef idx="1">
+            <a:schemeClr val="accent1"/>
+          </a:effectRef>
+          <a:fontRef idx="minor">
+            <a:schemeClr val="tx1"/>
+          </a:fontRef>
+        </p:style>
+      </p:cxnSp>
+      <p:sp>
+        <p:nvSpPr>
+          <p:cNvPr id="63" name="TextBox 62"/>
+          <p:cNvSpPr txBox="1"/>
+          <p:nvPr/>
+        </p:nvSpPr>
+        <p:spPr>
+          <a:xfrm>
+            <a:off x="9784080" y="3108960"/>
+            <a:ext cx="457200" cy="228600"/>
+          </a:xfrm>
+          <a:prstGeom prst="rect">
+            <a:avLst/>
+          </a:prstGeom>
+          <a:noFill/>
+        </p:spPr>
+        <p:txBody>
+          <a:bodyPr wrap="square" anchor="t" lIns="0" rIns="0" tIns="0" bIns="0">
+            <a:spAutoFit/>
+          </a:bodyPr>
+          <a:lstStyle/>
+          <a:p>
+            <a:r>
+              <a:rPr sz="900" b="1" i="0">
+                <a:solidFill>
+                  <a:srgbClr val="7A1B2E"/>
+                </a:solidFill>
+              </a:rPr>
+              <a:t>model</a:t>
+            </a:r>
+          </a:p>
+        </p:txBody>
+      </p:sp>
+      <p:sp>
+        <p:nvSpPr>
+          <p:cNvPr id="64" name="TextBox 63"/>
+          <p:cNvSpPr txBox="1"/>
+          <p:nvPr/>
+        </p:nvSpPr>
+        <p:spPr>
+          <a:xfrm>
+            <a:off x="6629400" y="4572000"/>
+            <a:ext cx="3566160" cy="274320"/>
+          </a:xfrm>
+          <a:prstGeom prst="rect">
+            <a:avLst/>
+          </a:prstGeom>
+          <a:noFill/>
+        </p:spPr>
+        <p:txBody>
+          <a:bodyPr wrap="square" anchor="t" lIns="0" rIns="0" tIns="0" bIns="0">
+            <a:spAutoFit/>
+          </a:bodyPr>
+          <a:lstStyle/>
+          <a:p>
+            <a:r>
+              <a:rPr sz="900" b="0" i="1">
+                <a:solidFill>
+                  <a:srgbClr val="5A6673"/>
+                </a:solidFill>
+              </a:rPr>
+              <a:t>state: 30 h history + checkpoint (HDFS)</a:t>
+            </a:r>
+          </a:p>
+        </p:txBody>
+      </p:sp>
+      <p:cxnSp>
+        <p:nvCxnSpPr>
+          <p:cNvPr id="65" name="Connector 64"/>
+          <p:cNvCxnSpPr/>
+          <p:nvPr/>
+        </p:nvCxnSpPr>
+        <p:spPr>
+          <a:xfrm>
+            <a:off x="6263640" y="2286000"/>
+            <a:ext cx="228600" cy="0"/>
+          </a:xfrm>
+          <a:prstGeom prst="line">
+            <a:avLst/>
+          </a:prstGeom>
+          <a:ln w="25400">
+            <a:solidFill>
+              <a:srgbClr val="6B7785"/>
+            </a:solidFill>
+            <a:tailEnd type="triangle"/>
+          </a:ln>
+        </p:spPr>
+        <p:style>
+          <a:lnRef idx="2">
+            <a:schemeClr val="accent1"/>
+          </a:lnRef>
+          <a:fillRef idx="0">
+            <a:schemeClr val="accent1"/>
+          </a:fillRef>
+          <a:effectRef idx="1">
+            <a:schemeClr val="accent1"/>
+          </a:effectRef>
+          <a:fontRef idx="minor">
+            <a:schemeClr val="tx1"/>
+          </a:fontRef>
+        </p:style>
+      </p:cxnSp>
+      <p:cxnSp>
+        <p:nvCxnSpPr>
+          <p:cNvPr id="66" name="Connector 65"/>
+          <p:cNvCxnSpPr/>
+          <p:nvPr/>
+        </p:nvCxnSpPr>
+        <p:spPr>
+          <a:xfrm flipH="1">
+            <a:off x="6263640" y="2651760"/>
+            <a:ext cx="228600" cy="0"/>
+          </a:xfrm>
+          <a:prstGeom prst="line">
+            <a:avLst/>
+          </a:prstGeom>
+          <a:ln w="25400">
+            <a:solidFill>
+              <a:srgbClr val="6B7785"/>
+            </a:solidFill>
+            <a:tailEnd type="triangle"/>
+          </a:ln>
+        </p:spPr>
+        <p:style>
+          <a:lnRef idx="2">
+            <a:schemeClr val="accent1"/>
+          </a:lnRef>
+          <a:fillRef idx="0">
+            <a:schemeClr val="accent1"/>
+          </a:fillRef>
+          <a:effectRef idx="1">
+            <a:schemeClr val="accent1"/>
+          </a:effectRef>
+          <a:fontRef idx="minor">
+            <a:schemeClr val="tx1"/>
+          </a:fontRef>
+        </p:style>
+      </p:cxnSp>
+      <p:cxnSp>
+        <p:nvCxnSpPr>
+          <p:cNvPr id="67" name="Connector 66"/>
+          <p:cNvCxnSpPr/>
+          <p:nvPr/>
+        </p:nvCxnSpPr>
+        <p:spPr>
+          <a:xfrm>
+            <a:off x="6263640" y="3840480"/>
+            <a:ext cx="228600" cy="0"/>
+          </a:xfrm>
+          <a:prstGeom prst="line">
+            <a:avLst/>
+          </a:prstGeom>
+          <a:ln w="25400">
+            <a:solidFill>
+              <a:srgbClr val="6B7785"/>
+            </a:solidFill>
+            <a:tailEnd type="triangle"/>
+          </a:ln>
+        </p:spPr>
+        <p:style>
+          <a:lnRef idx="2">
+            <a:schemeClr val="accent1"/>
+          </a:lnRef>
+          <a:fillRef idx="0">
+            <a:schemeClr val="accent1"/>
+          </a:fillRef>
+          <a:effectRef idx="1">
+            <a:schemeClr val="accent1"/>
+          </a:effectRef>
+          <a:fontRef idx="minor">
+            <a:schemeClr val="tx1"/>
+          </a:fontRef>
+        </p:style>
+      </p:cxnSp>
+      <p:cxnSp>
+        <p:nvCxnSpPr>
+          <p:cNvPr id="68" name="Connector 67"/>
+          <p:cNvCxnSpPr/>
+          <p:nvPr/>
+        </p:nvCxnSpPr>
+        <p:spPr>
+          <a:xfrm flipH="1">
+            <a:off x="6263640" y="4206240"/>
+            <a:ext cx="228600" cy="0"/>
+          </a:xfrm>
+          <a:prstGeom prst="line">
+            <a:avLst/>
+          </a:prstGeom>
+          <a:ln w="25400">
+            <a:solidFill>
+              <a:srgbClr val="6B7785"/>
+            </a:solidFill>
+            <a:tailEnd type="triangle"/>
+          </a:ln>
+        </p:spPr>
+        <p:style>
+          <a:lnRef idx="2">
+            <a:schemeClr val="accent1"/>
+          </a:lnRef>
+          <a:fillRef idx="0">
+            <a:schemeClr val="accent1"/>
+          </a:fillRef>
+          <a:effectRef idx="1">
+            <a:schemeClr val="accent1"/>
+          </a:effectRef>
+          <a:fontRef idx="minor">
+            <a:schemeClr val="tx1"/>
+          </a:fontRef>
+        </p:style>
+      </p:cxnSp>
+      <p:sp>
+        <p:nvSpPr>
+          <p:cNvPr id="69" name="Rectangle 68"/>
+          <p:cNvSpPr/>
+          <p:nvPr/>
+        </p:nvSpPr>
+        <p:spPr>
+          <a:xfrm>
+            <a:off x="10515600" y="1463040"/>
+            <a:ext cx="1280160" cy="731520"/>
+          </a:xfrm>
+          <a:prstGeom prst="rect">
+            <a:avLst/>
+          </a:prstGeom>
+          <a:solidFill>
+            <a:srgbClr val="0D3B5E"/>
+          </a:solidFill>
+          <a:ln>
+            <a:noFill/>
+          </a:ln>
+          <a:effectLst/>
+        </p:spPr>
+        <p:style>
+          <a:lnRef idx="1">
+            <a:schemeClr val="accent1"/>
+          </a:lnRef>
+          <a:fillRef idx="3">
+            <a:schemeClr val="accent1"/>
+          </a:fillRef>
+          <a:effectRef idx="2">
+            <a:schemeClr val="accent1"/>
+          </a:effectRef>
+          <a:fontRef idx="minor">
+            <a:schemeClr val="lt1"/>
+          </a:fontRef>
+        </p:style>
+        <p:txBody>
+          <a:bodyPr rtlCol="0" anchor="ctr"/>
+          <a:lstStyle/>
+          <a:p>
+            <a:pPr algn="ctr"/>
+          </a:p>
+        </p:txBody>
+      </p:sp>
+      <p:sp>
+        <p:nvSpPr>
+          <p:cNvPr id="70" name="TextBox 69"/>
+          <p:cNvSpPr txBox="1"/>
+          <p:nvPr/>
+        </p:nvSpPr>
+        <p:spPr>
+          <a:xfrm>
+            <a:off x="10561320" y="1463040"/>
+            <a:ext cx="1188719" cy="731520"/>
+          </a:xfrm>
+          <a:prstGeom prst="rect">
+            <a:avLst/>
+          </a:prstGeom>
+          <a:noFill/>
+        </p:spPr>
+        <p:txBody>
+          <a:bodyPr wrap="square" anchor="ctr" lIns="0" rIns="0" tIns="0" bIns="0">
+            <a:spAutoFit/>
+          </a:bodyPr>
+          <a:lstStyle/>
+          <a:p>
+            <a:pPr algn="ctr"/>
+            <a:r>
+              <a:rPr sz="1000" b="1" i="0">
+                <a:solidFill>
+                  <a:srgbClr val="FFFFFF"/>
+                </a:solidFill>
+              </a:rPr>
+              <a:t>Hive</a:t>
+            </a:r>
+          </a:p>
+          <a:p>
+            <a:pPr algn="ctr"/>
+            <a:r>
+              <a:rPr sz="1000" b="1" i="0">
+                <a:solidFill>
+                  <a:srgbClr val="FFFFFF"/>
+                </a:solidFill>
+              </a:rPr>
+              <a:t>external tables</a:t>
+            </a:r>
+          </a:p>
+        </p:txBody>
+      </p:sp>
+      <p:sp>
+        <p:nvSpPr>
+          <p:cNvPr id="71" name="Rectangle 70"/>
+          <p:cNvSpPr/>
+          <p:nvPr/>
+        </p:nvSpPr>
+        <p:spPr>
+          <a:xfrm>
+            <a:off x="10515600" y="2514600"/>
+            <a:ext cx="1280160" cy="731520"/>
+          </a:xfrm>
+          <a:prstGeom prst="rect">
+            <a:avLst/>
+          </a:prstGeom>
+          <a:solidFill>
+            <a:srgbClr val="0D3B5E"/>
+          </a:solidFill>
+          <a:ln>
+            <a:noFill/>
+          </a:ln>
+          <a:effectLst/>
+        </p:spPr>
+        <p:style>
+          <a:lnRef idx="1">
+            <a:schemeClr val="accent1"/>
+          </a:lnRef>
+          <a:fillRef idx="3">
+            <a:schemeClr val="accent1"/>
+          </a:fillRef>
+          <a:effectRef idx="2">
+            <a:schemeClr val="accent1"/>
+          </a:effectRef>
+          <a:fontRef idx="minor">
+            <a:schemeClr val="lt1"/>
+          </a:fontRef>
+        </p:style>
+        <p:txBody>
+          <a:bodyPr rtlCol="0" anchor="ctr"/>
+          <a:lstStyle/>
+          <a:p>
+            <a:pPr algn="ctr"/>
+          </a:p>
+        </p:txBody>
+      </p:sp>
+      <p:sp>
+        <p:nvSpPr>
+          <p:cNvPr id="72" name="TextBox 71"/>
+          <p:cNvSpPr txBox="1"/>
+          <p:nvPr/>
+        </p:nvSpPr>
+        <p:spPr>
+          <a:xfrm>
+            <a:off x="10561320" y="2514600"/>
+            <a:ext cx="1188719" cy="731520"/>
+          </a:xfrm>
+          <a:prstGeom prst="rect">
+            <a:avLst/>
+          </a:prstGeom>
+          <a:noFill/>
+        </p:spPr>
+        <p:txBody>
+          <a:bodyPr wrap="square" anchor="ctr" lIns="0" rIns="0" tIns="0" bIns="0">
+            <a:spAutoFit/>
+          </a:bodyPr>
+          <a:lstStyle/>
+          <a:p>
+            <a:pPr algn="ctr"/>
+            <a:r>
+              <a:rPr sz="1000" b="1" i="0">
+                <a:solidFill>
+                  <a:srgbClr val="FFFFFF"/>
+                </a:solidFill>
+              </a:rPr>
+              <a:t>Warning board</a:t>
+            </a:r>
+          </a:p>
+          <a:p>
+            <a:pPr algn="ctr"/>
+            <a:r>
+              <a:rPr sz="1000" b="1" i="0">
+                <a:solidFill>
+                  <a:srgbClr val="FFFFFF"/>
+                </a:solidFill>
+              </a:rPr>
+              <a:t>(HTML / Pages)</a:t>
+            </a:r>
+          </a:p>
+        </p:txBody>
+      </p:sp>
+      <p:sp>
+        <p:nvSpPr>
+          <p:cNvPr id="73" name="Rectangle 72"/>
+          <p:cNvSpPr/>
+          <p:nvPr/>
+        </p:nvSpPr>
+        <p:spPr>
+          <a:xfrm>
+            <a:off x="10515600" y="3566160"/>
+            <a:ext cx="1280160" cy="731520"/>
+          </a:xfrm>
+          <a:prstGeom prst="rect">
+            <a:avLst/>
+          </a:prstGeom>
+          <a:solidFill>
+            <a:srgbClr val="7A1B2E"/>
+          </a:solidFill>
+          <a:ln>
+            <a:noFill/>
+          </a:ln>
+          <a:effectLst/>
+        </p:spPr>
+        <p:style>
+          <a:lnRef idx="1">
+            <a:schemeClr val="accent1"/>
+          </a:lnRef>
+          <a:fillRef idx="3">
+            <a:schemeClr val="accent1"/>
+          </a:fillRef>
+          <a:effectRef idx="2">
+            <a:schemeClr val="accent1"/>
+          </a:effectRef>
+          <a:fontRef idx="minor">
+            <a:schemeClr val="lt1"/>
+          </a:fontRef>
+        </p:style>
+        <p:txBody>
+          <a:bodyPr rtlCol="0" anchor="ctr"/>
+          <a:lstStyle/>
+          <a:p>
+            <a:pPr algn="ctr"/>
+          </a:p>
+        </p:txBody>
+      </p:sp>
+      <p:sp>
+        <p:nvSpPr>
+          <p:cNvPr id="74" name="TextBox 73"/>
+          <p:cNvSpPr txBox="1"/>
+          <p:nvPr/>
+        </p:nvSpPr>
+        <p:spPr>
+          <a:xfrm>
+            <a:off x="10561320" y="3566160"/>
+            <a:ext cx="1188719" cy="731520"/>
+          </a:xfrm>
+          <a:prstGeom prst="rect">
+            <a:avLst/>
+          </a:prstGeom>
+          <a:noFill/>
+        </p:spPr>
+        <p:txBody>
+          <a:bodyPr wrap="square" anchor="ctr" lIns="0" rIns="0" tIns="0" bIns="0">
+            <a:spAutoFit/>
+          </a:bodyPr>
+          <a:lstStyle/>
+          <a:p>
+            <a:pPr algn="ctr"/>
+            <a:r>
+              <a:rPr sz="1000" b="1" i="0">
+                <a:solidFill>
+                  <a:srgbClr val="FFFFFF"/>
+                </a:solidFill>
+              </a:rPr>
+              <a:t>Alert engine</a:t>
+            </a:r>
+          </a:p>
+          <a:p>
+            <a:pPr algn="ctr"/>
+            <a:r>
+              <a:rPr sz="1000" b="1" i="0">
+                <a:solidFill>
+                  <a:srgbClr val="FFFFFF"/>
+                </a:solidFill>
+              </a:rPr>
+              <a:t>AQI &gt; 150</a:t>
+            </a:r>
+          </a:p>
+        </p:txBody>
+      </p:sp>
+      <p:sp>
+        <p:nvSpPr>
+          <p:cNvPr id="75" name="Rectangle 74"/>
+          <p:cNvSpPr/>
+          <p:nvPr/>
+        </p:nvSpPr>
+        <p:spPr>
+          <a:xfrm>
+            <a:off x="10515600" y="4617720"/>
+            <a:ext cx="1280160" cy="411480"/>
+          </a:xfrm>
+          <a:prstGeom prst="rect">
+            <a:avLst/>
+          </a:prstGeom>
+          <a:solidFill>
+            <a:srgbClr val="0E7C86"/>
+          </a:solidFill>
+          <a:ln>
+            <a:noFill/>
+          </a:ln>
+          <a:effectLst/>
+        </p:spPr>
+        <p:style>
+          <a:lnRef idx="1">
+            <a:schemeClr val="accent1"/>
+          </a:lnRef>
+          <a:fillRef idx="3">
+            <a:schemeClr val="accent1"/>
+          </a:fillRef>
+          <a:effectRef idx="2">
+            <a:schemeClr val="accent1"/>
+          </a:effectRef>
+          <a:fontRef idx="minor">
+            <a:schemeClr val="lt1"/>
+          </a:fontRef>
+        </p:style>
+        <p:txBody>
+          <a:bodyPr rtlCol="0" anchor="ctr"/>
+          <a:lstStyle/>
+          <a:p>
+            <a:pPr algn="ctr"/>
+          </a:p>
+        </p:txBody>
+      </p:sp>
+      <p:sp>
+        <p:nvSpPr>
+          <p:cNvPr id="76" name="TextBox 75"/>
+          <p:cNvSpPr txBox="1"/>
+          <p:nvPr/>
+        </p:nvSpPr>
+        <p:spPr>
+          <a:xfrm>
+            <a:off x="10561320" y="4617720"/>
+            <a:ext cx="1188719" cy="411480"/>
+          </a:xfrm>
+          <a:prstGeom prst="rect">
+            <a:avLst/>
+          </a:prstGeom>
+          <a:noFill/>
+        </p:spPr>
+        <p:txBody>
+          <a:bodyPr wrap="square" anchor="ctr" lIns="0" rIns="0" tIns="0" bIns="0">
+            <a:spAutoFit/>
+          </a:bodyPr>
+          <a:lstStyle/>
+          <a:p>
+            <a:pPr algn="ctr"/>
+            <a:r>
+              <a:rPr sz="1000" b="1" i="0">
+                <a:solidFill>
+                  <a:srgbClr val="FFFFFF"/>
+                </a:solidFill>
+              </a:rPr>
+              <a:t>Telegram</a:t>
+            </a:r>
+          </a:p>
+        </p:txBody>
+      </p:sp>
+      <p:cxnSp>
+        <p:nvCxnSpPr>
+          <p:cNvPr id="77" name="Connector 76"/>
+          <p:cNvCxnSpPr/>
+          <p:nvPr/>
+        </p:nvCxnSpPr>
+        <p:spPr>
+          <a:xfrm>
+            <a:off x="10287000" y="1828800"/>
+            <a:ext cx="228600" cy="0"/>
+          </a:xfrm>
+          <a:prstGeom prst="line">
+            <a:avLst/>
+          </a:prstGeom>
+          <a:ln w="25400">
+            <a:solidFill>
+              <a:srgbClr val="6B7785"/>
+            </a:solidFill>
+            <a:tailEnd type="triangle"/>
+          </a:ln>
+        </p:spPr>
+        <p:style>
+          <a:lnRef idx="2">
+            <a:schemeClr val="accent1"/>
+          </a:lnRef>
+          <a:fillRef idx="0">
+            <a:schemeClr val="accent1"/>
+          </a:fillRef>
+          <a:effectRef idx="1">
+            <a:schemeClr val="accent1"/>
+          </a:effectRef>
+          <a:fontRef idx="minor">
+            <a:schemeClr val="tx1"/>
+          </a:fontRef>
+        </p:style>
+      </p:cxnSp>
+      <p:cxnSp>
+        <p:nvCxnSpPr>
+          <p:cNvPr id="78" name="Connector 77"/>
+          <p:cNvCxnSpPr/>
+          <p:nvPr/>
+        </p:nvCxnSpPr>
+        <p:spPr>
+          <a:xfrm>
+            <a:off x="10287000" y="3931920"/>
+            <a:ext cx="228600" cy="0"/>
+          </a:xfrm>
+          <a:prstGeom prst="line">
+            <a:avLst/>
+          </a:prstGeom>
+          <a:ln w="25400">
+            <a:solidFill>
+              <a:srgbClr val="6B7785"/>
+            </a:solidFill>
+            <a:tailEnd type="triangle"/>
+          </a:ln>
+        </p:spPr>
+        <p:style>
+          <a:lnRef idx="2">
+            <a:schemeClr val="accent1"/>
+          </a:lnRef>
+          <a:fillRef idx="0">
+            <a:schemeClr val="accent1"/>
+          </a:fillRef>
+          <a:effectRef idx="1">
+            <a:schemeClr val="accent1"/>
+          </a:effectRef>
+          <a:fontRef idx="minor">
+            <a:schemeClr val="tx1"/>
+          </a:fontRef>
+        </p:style>
+      </p:cxnSp>
+      <p:cxnSp>
+        <p:nvCxnSpPr>
+          <p:cNvPr id="79" name="Connector 78"/>
+          <p:cNvCxnSpPr/>
+          <p:nvPr/>
+        </p:nvCxnSpPr>
+        <p:spPr>
+          <a:xfrm>
+            <a:off x="11155680" y="2194560"/>
+            <a:ext cx="0" cy="320040"/>
+          </a:xfrm>
+          <a:prstGeom prst="line">
+            <a:avLst/>
+          </a:prstGeom>
+          <a:ln w="25400">
+            <a:solidFill>
+              <a:srgbClr val="6B7785"/>
+            </a:solidFill>
+            <a:tailEnd type="triangle"/>
+          </a:ln>
+        </p:spPr>
+        <p:style>
+          <a:lnRef idx="2">
+            <a:schemeClr val="accent1"/>
+          </a:lnRef>
+          <a:fillRef idx="0">
+            <a:schemeClr val="accent1"/>
+          </a:fillRef>
+          <a:effectRef idx="1">
+            <a:schemeClr val="accent1"/>
+          </a:effectRef>
+          <a:fontRef idx="minor">
+            <a:schemeClr val="tx1"/>
+          </a:fontRef>
+        </p:style>
+      </p:cxnSp>
+      <p:cxnSp>
+        <p:nvCxnSpPr>
+          <p:cNvPr id="80" name="Connector 79"/>
+          <p:cNvCxnSpPr/>
+          <p:nvPr/>
+        </p:nvCxnSpPr>
+        <p:spPr>
+          <a:xfrm>
+            <a:off x="11155680" y="4297680"/>
+            <a:ext cx="0" cy="320040"/>
+          </a:xfrm>
+          <a:prstGeom prst="line">
+            <a:avLst/>
+          </a:prstGeom>
+          <a:ln w="25400">
+            <a:solidFill>
+              <a:srgbClr val="6B7785"/>
+            </a:solidFill>
+            <a:tailEnd type="triangle"/>
+          </a:ln>
+        </p:spPr>
+        <p:style>
+          <a:lnRef idx="2">
+            <a:schemeClr val="accent1"/>
+          </a:lnRef>
+          <a:fillRef idx="0">
+            <a:schemeClr val="accent1"/>
+          </a:fillRef>
+          <a:effectRef idx="1">
+            <a:schemeClr val="accent1"/>
+          </a:effectRef>
+          <a:fontRef idx="minor">
+            <a:schemeClr val="tx1"/>
+          </a:fontRef>
+        </p:style>
+      </p:cxnSp>
+      <p:sp>
+        <p:nvSpPr>
+          <p:cNvPr id="81" name="Rectangle 80"/>
+          <p:cNvSpPr/>
+          <p:nvPr/>
+        </p:nvSpPr>
+        <p:spPr>
+          <a:xfrm>
+            <a:off x="411480" y="5349240"/>
+            <a:ext cx="2194560" cy="457200"/>
+          </a:xfrm>
+          <a:prstGeom prst="rect">
+            <a:avLst/>
+          </a:prstGeom>
+          <a:solidFill>
+            <a:srgbClr val="F1F5F8"/>
           </a:solidFill>
           <a:ln w="6350">
             <a:solidFill>
@@ -12911,14 +15183,14 @@
       </p:sp>
       <p:sp>
         <p:nvSpPr>
-          <p:cNvPr id="23" name="TextBox 22"/>
+          <p:cNvPr id="82" name="TextBox 81"/>
           <p:cNvSpPr txBox="1"/>
           <p:nvPr/>
         </p:nvSpPr>
         <p:spPr>
           <a:xfrm>
-            <a:off x="6309360" y="1417320"/>
-            <a:ext cx="3291840" cy="274320"/>
+            <a:off x="457200" y="5349240"/>
+            <a:ext cx="2103120" cy="457200"/>
           </a:xfrm>
           <a:prstGeom prst="rect">
             <a:avLst/>
@@ -12926,41 +15198,44 @@
           <a:noFill/>
         </p:spPr>
         <p:txBody>
-          <a:bodyPr wrap="square" anchor="t" lIns="0" rIns="0" tIns="0" bIns="0">
+          <a:bodyPr wrap="square" anchor="ctr" lIns="0" rIns="0" tIns="0" bIns="0">
             <a:spAutoFit/>
           </a:bodyPr>
           <a:lstStyle/>
           <a:p>
-            <a:r>
-              <a:rPr sz="1100" b="1" i="0">
-                <a:solidFill>
-                  <a:srgbClr val="0B5F8A"/>
-                </a:solidFill>
-              </a:rPr>
-              <a:t>Scala 2.12 jobs (sbt jar)</a:t>
-            </a:r>
-          </a:p>
-        </p:txBody>
-      </p:sp>
-      <p:sp>
-        <p:nvSpPr>
-          <p:cNvPr id="24" name="Rectangle 23"/>
+            <a:pPr algn="ctr"/>
+            <a:r>
+              <a:rPr sz="1000" b="0" i="0">
+                <a:solidFill>
+                  <a:srgbClr val="1A1A1A"/>
+                </a:solidFill>
+              </a:rPr>
+              <a:t>Docker Compose · 11 containers</a:t>
+            </a:r>
+          </a:p>
+        </p:txBody>
+      </p:sp>
+      <p:sp>
+        <p:nvSpPr>
+          <p:cNvPr id="83" name="Rectangle 82"/>
           <p:cNvSpPr/>
           <p:nvPr/>
         </p:nvSpPr>
         <p:spPr>
           <a:xfrm>
-            <a:off x="6309360" y="1737360"/>
-            <a:ext cx="1600200" cy="731520"/>
+            <a:off x="2697480" y="5349240"/>
+            <a:ext cx="2194560" cy="457200"/>
           </a:xfrm>
           <a:prstGeom prst="rect">
             <a:avLst/>
           </a:prstGeom>
           <a:solidFill>
-            <a:srgbClr val="DCEBF4"/>
+            <a:srgbClr val="F1F5F8"/>
           </a:solidFill>
-          <a:ln>
-            <a:noFill/>
+          <a:ln w="6350">
+            <a:solidFill>
+              <a:srgbClr val="D9DFE7"/>
+            </a:solidFill>
           </a:ln>
           <a:effectLst/>
         </p:spPr>
@@ -12988,14 +15263,14 @@
       </p:sp>
       <p:sp>
         <p:nvSpPr>
-          <p:cNvPr id="25" name="TextBox 24"/>
+          <p:cNvPr id="84" name="TextBox 83"/>
           <p:cNvSpPr txBox="1"/>
           <p:nvPr/>
         </p:nvSpPr>
         <p:spPr>
           <a:xfrm>
-            <a:off x="6364224" y="1737360"/>
-            <a:ext cx="1490472" cy="731520"/>
+            <a:off x="2743200" y="5349240"/>
+            <a:ext cx="2103120" cy="457200"/>
           </a:xfrm>
           <a:prstGeom prst="rect">
             <a:avLst/>
@@ -13010,46 +15285,37 @@
           <a:p>
             <a:pPr algn="ctr"/>
             <a:r>
-              <a:rPr sz="1100" b="1" i="0">
+              <a:rPr sz="1000" b="0" i="0">
                 <a:solidFill>
                   <a:srgbClr val="1A1A1A"/>
                 </a:solidFill>
               </a:rPr>
-              <a:t>CleanSelect</a:t>
-            </a:r>
-          </a:p>
-          <a:p>
-            <a:pPr algn="ctr"/>
-            <a:r>
-              <a:rPr sz="1100" b="1" i="0">
-                <a:solidFill>
-                  <a:srgbClr val="1A1A1A"/>
-                </a:solidFill>
-              </a:rPr>
-              <a:t>clean + impute</a:t>
-            </a:r>
-          </a:p>
-        </p:txBody>
-      </p:sp>
-      <p:sp>
-        <p:nvSpPr>
-          <p:cNvPr id="26" name="Rectangle 25"/>
+              <a:t>HDFS 128 MB blocks · 3× replication</a:t>
+            </a:r>
+          </a:p>
+        </p:txBody>
+      </p:sp>
+      <p:sp>
+        <p:nvSpPr>
+          <p:cNvPr id="85" name="Rectangle 84"/>
           <p:cNvSpPr/>
           <p:nvPr/>
         </p:nvSpPr>
         <p:spPr>
           <a:xfrm>
-            <a:off x="8046720" y="1737360"/>
-            <a:ext cx="1600200" cy="731520"/>
+            <a:off x="4983480" y="5349240"/>
+            <a:ext cx="2194560" cy="457200"/>
           </a:xfrm>
           <a:prstGeom prst="rect">
             <a:avLst/>
           </a:prstGeom>
           <a:solidFill>
-            <a:srgbClr val="DCEBF4"/>
+            <a:srgbClr val="F1F5F8"/>
           </a:solidFill>
-          <a:ln>
-            <a:noFill/>
+          <a:ln w="6350">
+            <a:solidFill>
+              <a:srgbClr val="D9DFE7"/>
+            </a:solidFill>
           </a:ln>
           <a:effectLst/>
         </p:spPr>
@@ -13077,14 +15343,14 @@
       </p:sp>
       <p:sp>
         <p:nvSpPr>
-          <p:cNvPr id="27" name="TextBox 26"/>
+          <p:cNvPr id="86" name="TextBox 85"/>
           <p:cNvSpPr txBox="1"/>
           <p:nvPr/>
         </p:nvSpPr>
         <p:spPr>
           <a:xfrm>
-            <a:off x="8101584" y="1737360"/>
-            <a:ext cx="1490472" cy="731520"/>
+            <a:off x="5029200" y="5349240"/>
+            <a:ext cx="2103120" cy="457200"/>
           </a:xfrm>
           <a:prstGeom prst="rect">
             <a:avLst/>
@@ -13099,46 +15365,37 @@
           <a:p>
             <a:pPr algn="ctr"/>
             <a:r>
-              <a:rPr sz="1100" b="1" i="0">
+              <a:rPr sz="1000" b="0" i="0">
                 <a:solidFill>
                   <a:srgbClr val="1A1A1A"/>
                 </a:solidFill>
               </a:rPr>
-              <a:t>FeatureExtraction</a:t>
-            </a:r>
-          </a:p>
-          <a:p>
-            <a:pPr algn="ctr"/>
-            <a:r>
-              <a:rPr sz="1100" b="1" i="0">
-                <a:solidFill>
-                  <a:srgbClr val="1A1A1A"/>
-                </a:solidFill>
-              </a:rPr>
-              <a:t>86 features</a:t>
-            </a:r>
-          </a:p>
-        </p:txBody>
-      </p:sp>
-      <p:sp>
-        <p:nvSpPr>
-          <p:cNvPr id="28" name="Rectangle 27"/>
+              <a:t>Parquet (snappy), partitioned by city</a:t>
+            </a:r>
+          </a:p>
+        </p:txBody>
+      </p:sp>
+      <p:sp>
+        <p:nvSpPr>
+          <p:cNvPr id="87" name="Rectangle 86"/>
           <p:cNvSpPr/>
           <p:nvPr/>
         </p:nvSpPr>
         <p:spPr>
           <a:xfrm>
-            <a:off x="6309360" y="2560320"/>
-            <a:ext cx="1600200" cy="731520"/>
+            <a:off x="7269480" y="5349240"/>
+            <a:ext cx="2194560" cy="457200"/>
           </a:xfrm>
           <a:prstGeom prst="rect">
             <a:avLst/>
           </a:prstGeom>
           <a:solidFill>
-            <a:srgbClr val="DCEBF4"/>
+            <a:srgbClr val="F1F5F8"/>
           </a:solidFill>
-          <a:ln>
-            <a:noFill/>
+          <a:ln w="6350">
+            <a:solidFill>
+              <a:srgbClr val="D9DFE7"/>
+            </a:solidFill>
           </a:ln>
           <a:effectLst/>
         </p:spPr>
@@ -13166,14 +15423,14 @@
       </p:sp>
       <p:sp>
         <p:nvSpPr>
-          <p:cNvPr id="29" name="TextBox 28"/>
+          <p:cNvPr id="88" name="TextBox 87"/>
           <p:cNvSpPr txBox="1"/>
           <p:nvPr/>
         </p:nvSpPr>
         <p:spPr>
           <a:xfrm>
-            <a:off x="6364224" y="2560320"/>
-            <a:ext cx="1490472" cy="731520"/>
+            <a:off x="7315200" y="5349240"/>
+            <a:ext cx="2103120" cy="457200"/>
           </a:xfrm>
           <a:prstGeom prst="rect">
             <a:avLst/>
@@ -13188,46 +15445,37 @@
           <a:p>
             <a:pPr algn="ctr"/>
             <a:r>
-              <a:rPr sz="1100" b="1" i="0">
+              <a:rPr sz="1000" b="0" i="0">
                 <a:solidFill>
                   <a:srgbClr val="1A1A1A"/>
                 </a:solidFill>
               </a:rPr>
-              <a:t>LiveEnrichment</a:t>
-            </a:r>
-          </a:p>
-          <a:p>
-            <a:pPr algn="ctr"/>
-            <a:r>
-              <a:rPr sz="1100" b="1" i="0">
-                <a:solidFill>
-                  <a:srgbClr val="1A1A1A"/>
-                </a:solidFill>
-              </a:rPr>
-              <a:t>CAMS+weather</a:t>
-            </a:r>
-          </a:p>
-        </p:txBody>
-      </p:sp>
-      <p:sp>
-        <p:nvSpPr>
-          <p:cNvPr id="30" name="Rectangle 29"/>
+              <a:t>Scala 2.12.18 = Spark 3.5.6 build</a:t>
+            </a:r>
+          </a:p>
+        </p:txBody>
+      </p:sp>
+      <p:sp>
+        <p:nvSpPr>
+          <p:cNvPr id="89" name="Rectangle 88"/>
           <p:cNvSpPr/>
           <p:nvPr/>
         </p:nvSpPr>
         <p:spPr>
           <a:xfrm>
-            <a:off x="8046720" y="2560320"/>
-            <a:ext cx="1600200" cy="731520"/>
+            <a:off x="9555480" y="5349240"/>
+            <a:ext cx="2194560" cy="457200"/>
           </a:xfrm>
           <a:prstGeom prst="rect">
             <a:avLst/>
           </a:prstGeom>
           <a:solidFill>
-            <a:srgbClr val="D9EFF0"/>
+            <a:srgbClr val="F1F5F8"/>
           </a:solidFill>
-          <a:ln>
-            <a:noFill/>
+          <a:ln w="6350">
+            <a:solidFill>
+              <a:srgbClr val="D9DFE7"/>
+            </a:solidFill>
           </a:ln>
           <a:effectLst/>
         </p:spPr>
@@ -13255,14 +15503,14 @@
       </p:sp>
       <p:sp>
         <p:nvSpPr>
-          <p:cNvPr id="31" name="TextBox 30"/>
+          <p:cNvPr id="90" name="TextBox 89"/>
           <p:cNvSpPr txBox="1"/>
           <p:nvPr/>
         </p:nvSpPr>
         <p:spPr>
           <a:xfrm>
-            <a:off x="8101584" y="2560320"/>
-            <a:ext cx="1490472" cy="731520"/>
+            <a:off x="9601200" y="5349240"/>
+            <a:ext cx="2103120" cy="457200"/>
           </a:xfrm>
           <a:prstGeom prst="rect">
             <a:avLst/>
@@ -13277,37 +15525,26 @@
           <a:p>
             <a:pPr algn="ctr"/>
             <a:r>
-              <a:rPr sz="1100" b="1" i="0">
+              <a:rPr sz="1000" b="0" i="0">
                 <a:solidFill>
                   <a:srgbClr val="1A1A1A"/>
                 </a:solidFill>
               </a:rPr>
-              <a:t>AirQualityStream</a:t>
-            </a:r>
-          </a:p>
-          <a:p>
-            <a:pPr algn="ctr"/>
-            <a:r>
-              <a:rPr sz="1100" b="1" i="0">
-                <a:solidFill>
-                  <a:srgbClr val="1A1A1A"/>
-                </a:solidFill>
-              </a:rPr>
-              <a:t>10 s micro-batch</a:t>
-            </a:r>
-          </a:p>
-        </p:txBody>
-      </p:sp>
-      <p:sp>
-        <p:nvSpPr>
-          <p:cNvPr id="32" name="TextBox 31"/>
+              <a:t>Lambda: batch + speed over one lakehouse</a:t>
+            </a:r>
+          </a:p>
+        </p:txBody>
+      </p:sp>
+      <p:sp>
+        <p:nvSpPr>
+          <p:cNvPr id="91" name="TextBox 90"/>
           <p:cNvSpPr txBox="1"/>
           <p:nvPr/>
         </p:nvSpPr>
         <p:spPr>
           <a:xfrm>
-            <a:off x="6309360" y="3429000"/>
-            <a:ext cx="3291840" cy="274320"/>
+            <a:off x="411480" y="5989320"/>
+            <a:ext cx="11338560" cy="457200"/>
           </a:xfrm>
           <a:prstGeom prst="rect">
             <a:avLst/>
@@ -13321,614 +15558,12 @@
           <a:lstStyle/>
           <a:p>
             <a:r>
-              <a:rPr sz="1100" b="1" i="0">
-                <a:solidFill>
-                  <a:srgbClr val="0B5F8A"/>
-                </a:solidFill>
-              </a:rPr>
-              <a:t>PySpark + MLlib</a:t>
-            </a:r>
-          </a:p>
-        </p:txBody>
-      </p:sp>
-      <p:sp>
-        <p:nvSpPr>
-          <p:cNvPr id="33" name="Rectangle 32"/>
-          <p:cNvSpPr/>
-          <p:nvPr/>
-        </p:nvSpPr>
-        <p:spPr>
-          <a:xfrm>
-            <a:off x="6309360" y="3749039"/>
-            <a:ext cx="3337560" cy="640080"/>
-          </a:xfrm>
-          <a:prstGeom prst="rect">
-            <a:avLst/>
-          </a:prstGeom>
-          <a:solidFill>
-            <a:srgbClr val="7A1B2E"/>
-          </a:solidFill>
-          <a:ln>
-            <a:noFill/>
-          </a:ln>
-          <a:effectLst/>
-        </p:spPr>
-        <p:style>
-          <a:lnRef idx="1">
-            <a:schemeClr val="accent1"/>
-          </a:lnRef>
-          <a:fillRef idx="3">
-            <a:schemeClr val="accent1"/>
-          </a:fillRef>
-          <a:effectRef idx="2">
-            <a:schemeClr val="accent1"/>
-          </a:effectRef>
-          <a:fontRef idx="minor">
-            <a:schemeClr val="lt1"/>
-          </a:fontRef>
-        </p:style>
-        <p:txBody>
-          <a:bodyPr rtlCol="0" anchor="ctr"/>
-          <a:lstStyle/>
-          <a:p>
-            <a:pPr algn="ctr"/>
-          </a:p>
-        </p:txBody>
-      </p:sp>
-      <p:sp>
-        <p:nvSpPr>
-          <p:cNvPr id="34" name="TextBox 33"/>
-          <p:cNvSpPr txBox="1"/>
-          <p:nvPr/>
-        </p:nvSpPr>
-        <p:spPr>
-          <a:xfrm>
-            <a:off x="6364224" y="3749039"/>
-            <a:ext cx="3227832" cy="640080"/>
-          </a:xfrm>
-          <a:prstGeom prst="rect">
-            <a:avLst/>
-          </a:prstGeom>
-          <a:noFill/>
-        </p:spPr>
-        <p:txBody>
-          <a:bodyPr wrap="square" anchor="ctr" lIns="0" rIns="0" tIns="0" bIns="0">
-            <a:spAutoFit/>
-          </a:bodyPr>
-          <a:lstStyle/>
-          <a:p>
-            <a:pPr algn="ctr"/>
-            <a:r>
-              <a:rPr sz="1200" b="1" i="0">
-                <a:solidFill>
-                  <a:srgbClr val="FFFFFF"/>
-                </a:solidFill>
-              </a:rPr>
-              <a:t>GBTRegressor — 300 trees, delta target</a:t>
-            </a:r>
-          </a:p>
-        </p:txBody>
-      </p:sp>
-      <p:sp>
-        <p:nvSpPr>
-          <p:cNvPr id="35" name="Rectangle 34"/>
-          <p:cNvSpPr/>
-          <p:nvPr/>
-        </p:nvSpPr>
-        <p:spPr>
-          <a:xfrm>
-            <a:off x="6309360" y="4480560"/>
-            <a:ext cx="3337560" cy="594360"/>
-          </a:xfrm>
-          <a:prstGeom prst="rect">
-            <a:avLst/>
-          </a:prstGeom>
-          <a:solidFill>
-            <a:srgbClr val="DCEBF4"/>
-          </a:solidFill>
-          <a:ln>
-            <a:noFill/>
-          </a:ln>
-          <a:effectLst/>
-        </p:spPr>
-        <p:style>
-          <a:lnRef idx="1">
-            <a:schemeClr val="accent1"/>
-          </a:lnRef>
-          <a:fillRef idx="3">
-            <a:schemeClr val="accent1"/>
-          </a:fillRef>
-          <a:effectRef idx="2">
-            <a:schemeClr val="accent1"/>
-          </a:effectRef>
-          <a:fontRef idx="minor">
-            <a:schemeClr val="lt1"/>
-          </a:fontRef>
-        </p:style>
-        <p:txBody>
-          <a:bodyPr rtlCol="0" anchor="ctr"/>
-          <a:lstStyle/>
-          <a:p>
-            <a:pPr algn="ctr"/>
-          </a:p>
-        </p:txBody>
-      </p:sp>
-      <p:sp>
-        <p:nvSpPr>
-          <p:cNvPr id="36" name="TextBox 35"/>
-          <p:cNvSpPr txBox="1"/>
-          <p:nvPr/>
-        </p:nvSpPr>
-        <p:spPr>
-          <a:xfrm>
-            <a:off x="6364224" y="4480560"/>
-            <a:ext cx="3227832" cy="594360"/>
-          </a:xfrm>
-          <a:prstGeom prst="rect">
-            <a:avLst/>
-          </a:prstGeom>
-          <a:noFill/>
-        </p:spPr>
-        <p:txBody>
-          <a:bodyPr wrap="square" anchor="ctr" lIns="0" rIns="0" tIns="0" bIns="0">
-            <a:spAutoFit/>
-          </a:bodyPr>
-          <a:lstStyle/>
-          <a:p>
-            <a:pPr algn="ctr"/>
-            <a:r>
-              <a:rPr sz="1100" b="1" i="0">
-                <a:solidFill>
-                  <a:srgbClr val="1A1A1A"/>
-                </a:solidFill>
-              </a:rPr>
-              <a:t>Validation + cross-check (5 paired tests)</a:t>
-            </a:r>
-          </a:p>
-        </p:txBody>
-      </p:sp>
-      <p:cxnSp>
-        <p:nvCxnSpPr>
-          <p:cNvPr id="37" name="Connector 36"/>
-          <p:cNvCxnSpPr/>
-          <p:nvPr/>
-        </p:nvCxnSpPr>
-        <p:spPr>
-          <a:xfrm>
-            <a:off x="9738360" y="3291840"/>
-            <a:ext cx="502920" cy="0"/>
-          </a:xfrm>
-          <a:prstGeom prst="line">
-            <a:avLst/>
-          </a:prstGeom>
-          <a:ln w="25400">
-            <a:solidFill>
-              <a:srgbClr val="6B7785"/>
-            </a:solidFill>
-            <a:tailEnd type="triangle"/>
-          </a:ln>
-        </p:spPr>
-        <p:style>
-          <a:lnRef idx="2">
-            <a:schemeClr val="accent1"/>
-          </a:lnRef>
-          <a:fillRef idx="0">
-            <a:schemeClr val="accent1"/>
-          </a:fillRef>
-          <a:effectRef idx="1">
-            <a:schemeClr val="accent1"/>
-          </a:effectRef>
-          <a:fontRef idx="minor">
-            <a:schemeClr val="tx1"/>
-          </a:fontRef>
-        </p:style>
-      </p:cxnSp>
-      <p:sp>
-        <p:nvSpPr>
-          <p:cNvPr id="38" name="TextBox 37"/>
-          <p:cNvSpPr txBox="1"/>
-          <p:nvPr/>
-        </p:nvSpPr>
-        <p:spPr>
-          <a:xfrm>
-            <a:off x="10241280" y="1097280"/>
-            <a:ext cx="1463040" cy="274320"/>
-          </a:xfrm>
-          <a:prstGeom prst="rect">
-            <a:avLst/>
-          </a:prstGeom>
-          <a:noFill/>
-        </p:spPr>
-        <p:txBody>
-          <a:bodyPr wrap="square" anchor="t" lIns="0" rIns="0" tIns="0" bIns="0">
-            <a:spAutoFit/>
-          </a:bodyPr>
-          <a:lstStyle/>
-          <a:p>
-            <a:r>
-              <a:rPr sz="1100" b="1" i="0">
+              <a:rPr sz="1050" b="0" i="1">
                 <a:solidFill>
                   <a:srgbClr val="6B7785"/>
                 </a:solidFill>
               </a:rPr>
-              <a:t>OUTPUT</a:t>
-            </a:r>
-          </a:p>
-        </p:txBody>
-      </p:sp>
-      <p:sp>
-        <p:nvSpPr>
-          <p:cNvPr id="39" name="Rectangle 38"/>
-          <p:cNvSpPr/>
-          <p:nvPr/>
-        </p:nvSpPr>
-        <p:spPr>
-          <a:xfrm>
-            <a:off x="10241280" y="1371600"/>
-            <a:ext cx="1417320" cy="1097280"/>
-          </a:xfrm>
-          <a:prstGeom prst="rect">
-            <a:avLst/>
-          </a:prstGeom>
-          <a:solidFill>
-            <a:srgbClr val="0D3B5E"/>
-          </a:solidFill>
-          <a:ln>
-            <a:noFill/>
-          </a:ln>
-          <a:effectLst/>
-        </p:spPr>
-        <p:style>
-          <a:lnRef idx="1">
-            <a:schemeClr val="accent1"/>
-          </a:lnRef>
-          <a:fillRef idx="3">
-            <a:schemeClr val="accent1"/>
-          </a:fillRef>
-          <a:effectRef idx="2">
-            <a:schemeClr val="accent1"/>
-          </a:effectRef>
-          <a:fontRef idx="minor">
-            <a:schemeClr val="lt1"/>
-          </a:fontRef>
-        </p:style>
-        <p:txBody>
-          <a:bodyPr rtlCol="0" anchor="ctr"/>
-          <a:lstStyle/>
-          <a:p>
-            <a:pPr algn="ctr"/>
-          </a:p>
-        </p:txBody>
-      </p:sp>
-      <p:sp>
-        <p:nvSpPr>
-          <p:cNvPr id="40" name="TextBox 39"/>
-          <p:cNvSpPr txBox="1"/>
-          <p:nvPr/>
-        </p:nvSpPr>
-        <p:spPr>
-          <a:xfrm>
-            <a:off x="10296144" y="1371600"/>
-            <a:ext cx="1307592" cy="1097280"/>
-          </a:xfrm>
-          <a:prstGeom prst="rect">
-            <a:avLst/>
-          </a:prstGeom>
-          <a:noFill/>
-        </p:spPr>
-        <p:txBody>
-          <a:bodyPr wrap="square" anchor="ctr" lIns="0" rIns="0" tIns="0" bIns="0">
-            <a:spAutoFit/>
-          </a:bodyPr>
-          <a:lstStyle/>
-          <a:p>
-            <a:pPr algn="ctr"/>
-            <a:r>
-              <a:rPr sz="1100" b="1" i="0">
-                <a:solidFill>
-                  <a:srgbClr val="FFFFFF"/>
-                </a:solidFill>
-              </a:rPr>
-              <a:t>Hive</a:t>
-            </a:r>
-          </a:p>
-          <a:p>
-            <a:pPr algn="ctr"/>
-            <a:r>
-              <a:rPr sz="1100" b="1" i="0">
-                <a:solidFill>
-                  <a:srgbClr val="FFFFFF"/>
-                </a:solidFill>
-              </a:rPr>
-              <a:t>external</a:t>
-            </a:r>
-          </a:p>
-          <a:p>
-            <a:pPr algn="ctr"/>
-            <a:r>
-              <a:rPr sz="1100" b="1" i="0">
-                <a:solidFill>
-                  <a:srgbClr val="FFFFFF"/>
-                </a:solidFill>
-              </a:rPr>
-              <a:t>tables</a:t>
-            </a:r>
-          </a:p>
-        </p:txBody>
-      </p:sp>
-      <p:sp>
-        <p:nvSpPr>
-          <p:cNvPr id="41" name="Rectangle 40"/>
-          <p:cNvSpPr/>
-          <p:nvPr/>
-        </p:nvSpPr>
-        <p:spPr>
-          <a:xfrm>
-            <a:off x="10241280" y="2606040"/>
-            <a:ext cx="1417320" cy="1097280"/>
-          </a:xfrm>
-          <a:prstGeom prst="rect">
-            <a:avLst/>
-          </a:prstGeom>
-          <a:solidFill>
-            <a:srgbClr val="7A1B2E"/>
-          </a:solidFill>
-          <a:ln>
-            <a:noFill/>
-          </a:ln>
-          <a:effectLst/>
-        </p:spPr>
-        <p:style>
-          <a:lnRef idx="1">
-            <a:schemeClr val="accent1"/>
-          </a:lnRef>
-          <a:fillRef idx="3">
-            <a:schemeClr val="accent1"/>
-          </a:fillRef>
-          <a:effectRef idx="2">
-            <a:schemeClr val="accent1"/>
-          </a:effectRef>
-          <a:fontRef idx="minor">
-            <a:schemeClr val="lt1"/>
-          </a:fontRef>
-        </p:style>
-        <p:txBody>
-          <a:bodyPr rtlCol="0" anchor="ctr"/>
-          <a:lstStyle/>
-          <a:p>
-            <a:pPr algn="ctr"/>
-          </a:p>
-        </p:txBody>
-      </p:sp>
-      <p:sp>
-        <p:nvSpPr>
-          <p:cNvPr id="42" name="TextBox 41"/>
-          <p:cNvSpPr txBox="1"/>
-          <p:nvPr/>
-        </p:nvSpPr>
-        <p:spPr>
-          <a:xfrm>
-            <a:off x="10296144" y="2606040"/>
-            <a:ext cx="1307592" cy="1097280"/>
-          </a:xfrm>
-          <a:prstGeom prst="rect">
-            <a:avLst/>
-          </a:prstGeom>
-          <a:noFill/>
-        </p:spPr>
-        <p:txBody>
-          <a:bodyPr wrap="square" anchor="ctr" lIns="0" rIns="0" tIns="0" bIns="0">
-            <a:spAutoFit/>
-          </a:bodyPr>
-          <a:lstStyle/>
-          <a:p>
-            <a:pPr algn="ctr"/>
-            <a:r>
-              <a:rPr sz="1100" b="1" i="0">
-                <a:solidFill>
-                  <a:srgbClr val="FFFFFF"/>
-                </a:solidFill>
-              </a:rPr>
-              <a:t>Alert</a:t>
-            </a:r>
-          </a:p>
-          <a:p>
-            <a:pPr algn="ctr"/>
-            <a:r>
-              <a:rPr sz="1100" b="1" i="0">
-                <a:solidFill>
-                  <a:srgbClr val="FFFFFF"/>
-                </a:solidFill>
-              </a:rPr>
-              <a:t>engine</a:t>
-            </a:r>
-          </a:p>
-          <a:p>
-            <a:pPr algn="ctr"/>
-            <a:r>
-              <a:rPr sz="1100" b="1" i="0">
-                <a:solidFill>
-                  <a:srgbClr val="FFFFFF"/>
-                </a:solidFill>
-              </a:rPr>
-              <a:t>AQI &gt; 150</a:t>
-            </a:r>
-          </a:p>
-        </p:txBody>
-      </p:sp>
-      <p:sp>
-        <p:nvSpPr>
-          <p:cNvPr id="43" name="Rectangle 42"/>
-          <p:cNvSpPr/>
-          <p:nvPr/>
-        </p:nvSpPr>
-        <p:spPr>
-          <a:xfrm>
-            <a:off x="10241280" y="3840480"/>
-            <a:ext cx="1417320" cy="1371600"/>
-          </a:xfrm>
-          <a:prstGeom prst="rect">
-            <a:avLst/>
-          </a:prstGeom>
-          <a:solidFill>
-            <a:srgbClr val="0E7C86"/>
-          </a:solidFill>
-          <a:ln>
-            <a:noFill/>
-          </a:ln>
-          <a:effectLst/>
-        </p:spPr>
-        <p:style>
-          <a:lnRef idx="1">
-            <a:schemeClr val="accent1"/>
-          </a:lnRef>
-          <a:fillRef idx="3">
-            <a:schemeClr val="accent1"/>
-          </a:fillRef>
-          <a:effectRef idx="2">
-            <a:schemeClr val="accent1"/>
-          </a:effectRef>
-          <a:fontRef idx="minor">
-            <a:schemeClr val="lt1"/>
-          </a:fontRef>
-        </p:style>
-        <p:txBody>
-          <a:bodyPr rtlCol="0" anchor="ctr"/>
-          <a:lstStyle/>
-          <a:p>
-            <a:pPr algn="ctr"/>
-          </a:p>
-        </p:txBody>
-      </p:sp>
-      <p:sp>
-        <p:nvSpPr>
-          <p:cNvPr id="44" name="TextBox 43"/>
-          <p:cNvSpPr txBox="1"/>
-          <p:nvPr/>
-        </p:nvSpPr>
-        <p:spPr>
-          <a:xfrm>
-            <a:off x="10296144" y="3840480"/>
-            <a:ext cx="1307592" cy="1371600"/>
-          </a:xfrm>
-          <a:prstGeom prst="rect">
-            <a:avLst/>
-          </a:prstGeom>
-          <a:noFill/>
-        </p:spPr>
-        <p:txBody>
-          <a:bodyPr wrap="square" anchor="ctr" lIns="0" rIns="0" tIns="0" bIns="0">
-            <a:spAutoFit/>
-          </a:bodyPr>
-          <a:lstStyle/>
-          <a:p>
-            <a:pPr algn="ctr"/>
-            <a:r>
-              <a:rPr sz="1100" b="1" i="0">
-                <a:solidFill>
-                  <a:srgbClr val="FFFFFF"/>
-                </a:solidFill>
-              </a:rPr>
-              <a:t>Warning</a:t>
-            </a:r>
-          </a:p>
-          <a:p>
-            <a:pPr algn="ctr"/>
-            <a:r>
-              <a:rPr sz="1100" b="1" i="0">
-                <a:solidFill>
-                  <a:srgbClr val="FFFFFF"/>
-                </a:solidFill>
-              </a:rPr>
-              <a:t>board +</a:t>
-            </a:r>
-          </a:p>
-          <a:p>
-            <a:pPr algn="ctr"/>
-            <a:r>
-              <a:rPr sz="1100" b="1" i="0">
-                <a:solidFill>
-                  <a:srgbClr val="FFFFFF"/>
-                </a:solidFill>
-              </a:rPr>
-              <a:t>Telegram</a:t>
-            </a:r>
-          </a:p>
-        </p:txBody>
-      </p:sp>
-      <p:sp>
-        <p:nvSpPr>
-          <p:cNvPr id="45" name="Rectangle 44"/>
-          <p:cNvSpPr/>
-          <p:nvPr/>
-        </p:nvSpPr>
-        <p:spPr>
-          <a:xfrm>
-            <a:off x="548640" y="5440680"/>
-            <a:ext cx="11109960" cy="822960"/>
-          </a:xfrm>
-          <a:prstGeom prst="rect">
-            <a:avLst/>
-          </a:prstGeom>
-          <a:solidFill>
-            <a:srgbClr val="EAF2F8"/>
-          </a:solidFill>
-          <a:ln>
-            <a:noFill/>
-          </a:ln>
-          <a:effectLst/>
-        </p:spPr>
-        <p:style>
-          <a:lnRef idx="1">
-            <a:schemeClr val="accent1"/>
-          </a:lnRef>
-          <a:fillRef idx="3">
-            <a:schemeClr val="accent1"/>
-          </a:fillRef>
-          <a:effectRef idx="2">
-            <a:schemeClr val="accent1"/>
-          </a:effectRef>
-          <a:fontRef idx="minor">
-            <a:schemeClr val="lt1"/>
-          </a:fontRef>
-        </p:style>
-        <p:txBody>
-          <a:bodyPr rtlCol="0" anchor="ctr"/>
-          <a:lstStyle/>
-          <a:p>
-            <a:pPr algn="ctr"/>
-          </a:p>
-        </p:txBody>
-      </p:sp>
-      <p:sp>
-        <p:nvSpPr>
-          <p:cNvPr id="46" name="TextBox 45"/>
-          <p:cNvSpPr txBox="1"/>
-          <p:nvPr/>
-        </p:nvSpPr>
-        <p:spPr>
-          <a:xfrm>
-            <a:off x="713232" y="5495544"/>
-            <a:ext cx="10780776" cy="713232"/>
-          </a:xfrm>
-          <a:prstGeom prst="rect">
-            <a:avLst/>
-          </a:prstGeom>
-          <a:noFill/>
-        </p:spPr>
-        <p:txBody>
-          <a:bodyPr wrap="square" anchor="ctr" lIns="0" rIns="0" tIns="0" bIns="0">
-            <a:spAutoFit/>
-          </a:bodyPr>
-          <a:lstStyle/>
-          <a:p>
-            <a:r>
-              <a:rPr sz="1300" b="0" i="0">
-                <a:solidFill>
-                  <a:srgbClr val="1A1A1A"/>
-                </a:solidFill>
-              </a:rPr>
-              <a:t>Lambda-style: a batch layer trains on 13 years of history; a speed layer scores live data against the same model. The trained model is stored in HDFS and loaded by the streaming job.</a:t>
+              <a:t>Blue = storage · light = Scala jobs · maroon = ML model / alert logic · teal = live path. Arrows show data flow; the model is read from HDFS by the streaming job.</a:t>
             </a:r>
           </a:p>
         </p:txBody>
@@ -16694,8 +18329,8 @@
         </p:nvSpPr>
         <p:spPr>
           <a:xfrm>
-            <a:off x="603503" y="1188720"/>
-            <a:ext cx="1581912" cy="868680"/>
+            <a:off x="594360" y="1188720"/>
+            <a:ext cx="1600200" cy="868680"/>
           </a:xfrm>
           <a:prstGeom prst="rect">
             <a:avLst/>
@@ -16817,8 +18452,8 @@
         </p:nvSpPr>
         <p:spPr>
           <a:xfrm>
-            <a:off x="2478024" y="1188720"/>
-            <a:ext cx="1581912" cy="868680"/>
+            <a:off x="2468879" y="1188720"/>
+            <a:ext cx="1600200" cy="868680"/>
           </a:xfrm>
           <a:prstGeom prst="rect">
             <a:avLst/>
@@ -16940,8 +18575,8 @@
         </p:nvSpPr>
         <p:spPr>
           <a:xfrm>
-            <a:off x="4352543" y="1188720"/>
-            <a:ext cx="1581912" cy="868680"/>
+            <a:off x="4343399" y="1188720"/>
+            <a:ext cx="1600200" cy="868680"/>
           </a:xfrm>
           <a:prstGeom prst="rect">
             <a:avLst/>
@@ -17063,8 +18698,8 @@
         </p:nvSpPr>
         <p:spPr>
           <a:xfrm>
-            <a:off x="6227063" y="1188720"/>
-            <a:ext cx="1581912" cy="868680"/>
+            <a:off x="6217919" y="1188720"/>
+            <a:ext cx="1600200" cy="868680"/>
           </a:xfrm>
           <a:prstGeom prst="rect">
             <a:avLst/>
@@ -17186,8 +18821,8 @@
         </p:nvSpPr>
         <p:spPr>
           <a:xfrm>
-            <a:off x="8101583" y="1188720"/>
-            <a:ext cx="1581912" cy="868680"/>
+            <a:off x="8092440" y="1188720"/>
+            <a:ext cx="1600200" cy="868680"/>
           </a:xfrm>
           <a:prstGeom prst="rect">
             <a:avLst/>
@@ -17309,8 +18944,8 @@
         </p:nvSpPr>
         <p:spPr>
           <a:xfrm>
-            <a:off x="9976104" y="1188720"/>
-            <a:ext cx="1581912" cy="868680"/>
+            <a:off x="9966960" y="1188720"/>
+            <a:ext cx="1600200" cy="868680"/>
           </a:xfrm>
           <a:prstGeom prst="rect">
             <a:avLst/>

</xml_diff>